<commit_message>
Simplify slide 8: less text, cleaner before/after format
</commit_message>
<xml_diff>
--- a/presentation/DiabetesControl_AI_v5.pptx
+++ b/presentation/DiabetesControl_AI_v5.pptx
@@ -15310,7 +15310,7 @@
                 </a:solidFill>
                 <a:latin typeface="Segoe UI"/>
               </a:rPr>
-              <a:t>Why AI — Not Just a Form</a:t>
+              <a:t>Why AI?</a:t>
             </a:r>
           </a:p>
         </p:txBody>
@@ -15339,13 +15339,13 @@
           <a:p>
             <a:pPr algn="l"/>
             <a:r>
-              <a:rPr sz="2600" b="1">
+              <a:rPr sz="2800" b="1">
                 <a:solidFill>
                   <a:srgbClr val="1E293B"/>
                 </a:solidFill>
                 <a:latin typeface="Segoe UI"/>
               </a:rPr>
-              <a:t>What AI Does That Nothing Else Can</a:t>
+              <a:t>Regular App vs Our AI</a:t>
             </a:r>
           </a:p>
         </p:txBody>
@@ -15359,7 +15359,7 @@
         <p:spPr>
           <a:xfrm>
             <a:off x="457200" y="1234440"/>
-            <a:ext cx="10972800" cy="320040"/>
+            <a:ext cx="10972800" cy="274320"/>
           </a:xfrm>
           <a:prstGeom prst="rect">
             <a:avLst/>
@@ -15374,27 +15374,97 @@
           <a:p>
             <a:pPr algn="l"/>
             <a:r>
-              <a:rPr sz="1300" b="0">
-                <a:solidFill>
-                  <a:srgbClr val="64748B"/>
-                </a:solidFill>
-                <a:latin typeface="Segoe UI"/>
-              </a:rPr>
-              <a:t>A regular app collects data. Our app UNDERSTANDS it.</a:t>
-            </a:r>
-          </a:p>
-        </p:txBody>
-      </p:sp>
-      <p:sp>
-        <p:nvSpPr>
-          <p:cNvPr id="10" name="Rounded Rectangle 9"/>
+              <a:rPr sz="1400" b="1">
+                <a:solidFill>
+                  <a:srgbClr val="16A34A"/>
+                </a:solidFill>
+                <a:latin typeface="Segoe UI"/>
+              </a:rPr>
+              <a:t>A form collects data. Our AI understands it.</a:t>
+            </a:r>
+          </a:p>
+        </p:txBody>
+      </p:sp>
+      <p:sp>
+        <p:nvSpPr>
+          <p:cNvPr id="10" name="TextBox 9"/>
+          <p:cNvSpPr txBox="1"/>
+          <p:nvPr/>
+        </p:nvSpPr>
+        <p:spPr>
+          <a:xfrm>
+            <a:off x="457200" y="1737360"/>
+            <a:ext cx="5486400" cy="320040"/>
+          </a:xfrm>
+          <a:prstGeom prst="rect">
+            <a:avLst/>
+          </a:prstGeom>
+          <a:noFill/>
+        </p:spPr>
+        <p:txBody>
+          <a:bodyPr wrap="square" lIns="0" rIns="0" tIns="0" bIns="0" anchor="t">
+            <a:spAutoFit/>
+          </a:bodyPr>
+          <a:lstStyle/>
+          <a:p>
+            <a:pPr algn="l"/>
+            <a:r>
+              <a:rPr sz="1300" b="1">
+                <a:solidFill>
+                  <a:srgbClr val="DC2626"/>
+                </a:solidFill>
+                <a:latin typeface="Segoe UI"/>
+              </a:rPr>
+              <a:t>❌  Without AI</a:t>
+            </a:r>
+          </a:p>
+        </p:txBody>
+      </p:sp>
+      <p:sp>
+        <p:nvSpPr>
+          <p:cNvPr id="11" name="TextBox 10"/>
+          <p:cNvSpPr txBox="1"/>
+          <p:nvPr/>
+        </p:nvSpPr>
+        <p:spPr>
+          <a:xfrm>
+            <a:off x="6217920" y="1737360"/>
+            <a:ext cx="5486400" cy="320040"/>
+          </a:xfrm>
+          <a:prstGeom prst="rect">
+            <a:avLst/>
+          </a:prstGeom>
+          <a:noFill/>
+        </p:spPr>
+        <p:txBody>
+          <a:bodyPr wrap="square" lIns="0" rIns="0" tIns="0" bIns="0" anchor="t">
+            <a:spAutoFit/>
+          </a:bodyPr>
+          <a:lstStyle/>
+          <a:p>
+            <a:pPr algn="l"/>
+            <a:r>
+              <a:rPr sz="1300" b="1">
+                <a:solidFill>
+                  <a:srgbClr val="16A34A"/>
+                </a:solidFill>
+                <a:latin typeface="Segoe UI"/>
+              </a:rPr>
+              <a:t>✅  With Our AI</a:t>
+            </a:r>
+          </a:p>
+        </p:txBody>
+      </p:sp>
+      <p:sp>
+        <p:nvSpPr>
+          <p:cNvPr id="12" name="Rounded Rectangle 11"/>
           <p:cNvSpPr/>
           <p:nvPr/>
         </p:nvSpPr>
         <p:spPr>
           <a:xfrm>
-            <a:off x="457200" y="1737360"/>
-            <a:ext cx="5303520" cy="594360"/>
+            <a:off x="457200" y="2194560"/>
+            <a:ext cx="5577840" cy="777240"/>
           </a:xfrm>
           <a:prstGeom prst="roundRect">
             <a:avLst>
@@ -15434,14 +15504,14 @@
       </p:sp>
       <p:sp>
         <p:nvSpPr>
-          <p:cNvPr id="11" name="TextBox 10"/>
-          <p:cNvSpPr txBox="1"/>
-          <p:nvPr/>
-        </p:nvSpPr>
-        <p:spPr>
-          <a:xfrm>
-            <a:off x="640080" y="1810512"/>
-            <a:ext cx="5029200" cy="256032"/>
+          <p:cNvPr id="13" name="TextBox 12"/>
+          <p:cNvSpPr txBox="1"/>
+          <p:nvPr/>
+        </p:nvSpPr>
+        <p:spPr>
+          <a:xfrm>
+            <a:off x="640080" y="2286000"/>
+            <a:ext cx="5212080" cy="640080"/>
           </a:xfrm>
           <a:prstGeom prst="rect">
             <a:avLst/>
@@ -15456,62 +15526,28 @@
           <a:p>
             <a:pPr algn="l"/>
             <a:r>
-              <a:rPr sz="900" b="1">
-                <a:solidFill>
-                  <a:srgbClr val="DC2626"/>
-                </a:solidFill>
-                <a:latin typeface="Segoe UI"/>
-              </a:rPr>
-              <a:t>❌  WITHOUT AI:</a:t>
-            </a:r>
-          </a:p>
-        </p:txBody>
-      </p:sp>
-      <p:sp>
-        <p:nvSpPr>
-          <p:cNvPr id="12" name="TextBox 11"/>
-          <p:cNvSpPr txBox="1"/>
-          <p:nvPr/>
-        </p:nvSpPr>
-        <p:spPr>
-          <a:xfrm>
-            <a:off x="640080" y="2057400"/>
-            <a:ext cx="5029200" cy="256032"/>
-          </a:xfrm>
-          <a:prstGeom prst="rect">
-            <a:avLst/>
-          </a:prstGeom>
-          <a:noFill/>
-        </p:spPr>
-        <p:txBody>
-          <a:bodyPr wrap="square" lIns="0" rIns="0" tIns="0" bIns="0" anchor="t">
-            <a:spAutoFit/>
-          </a:bodyPr>
-          <a:lstStyle/>
-          <a:p>
-            <a:pPr algn="l"/>
-            <a:r>
               <a:rPr sz="1000" b="0">
                 <a:solidFill>
                   <a:srgbClr val="1E293B"/>
                 </a:solidFill>
                 <a:latin typeface="Segoe UI"/>
               </a:rPr>
-              <a:t>Patient uploads lab photo → nothing happens. Must type values manually.</a:t>
-            </a:r>
-          </a:p>
-        </p:txBody>
-      </p:sp>
-      <p:sp>
-        <p:nvSpPr>
-          <p:cNvPr id="13" name="Rounded Rectangle 12"/>
+              <a:t>Patient uploads lab photo
+→ Must type values manually</a:t>
+            </a:r>
+          </a:p>
+        </p:txBody>
+      </p:sp>
+      <p:sp>
+        <p:nvSpPr>
+          <p:cNvPr id="14" name="Rounded Rectangle 13"/>
           <p:cNvSpPr/>
           <p:nvPr/>
         </p:nvSpPr>
         <p:spPr>
           <a:xfrm>
-            <a:off x="5943600" y="1737360"/>
-            <a:ext cx="5760720" cy="594360"/>
+            <a:off x="6217920" y="2194560"/>
+            <a:ext cx="5577840" cy="777240"/>
           </a:xfrm>
           <a:prstGeom prst="roundRect">
             <a:avLst>
@@ -15551,14 +15587,14 @@
       </p:sp>
       <p:sp>
         <p:nvSpPr>
-          <p:cNvPr id="14" name="TextBox 13"/>
-          <p:cNvSpPr txBox="1"/>
-          <p:nvPr/>
-        </p:nvSpPr>
-        <p:spPr>
-          <a:xfrm>
-            <a:off x="6126480" y="1810512"/>
-            <a:ext cx="5394960" cy="256032"/>
+          <p:cNvPr id="15" name="TextBox 14"/>
+          <p:cNvSpPr txBox="1"/>
+          <p:nvPr/>
+        </p:nvSpPr>
+        <p:spPr>
+          <a:xfrm>
+            <a:off x="6400800" y="2286000"/>
+            <a:ext cx="5212080" cy="640080"/>
           </a:xfrm>
           <a:prstGeom prst="rect">
             <a:avLst/>
@@ -15573,48 +15609,14 @@
           <a:p>
             <a:pPr algn="l"/>
             <a:r>
-              <a:rPr sz="900" b="1">
-                <a:solidFill>
-                  <a:srgbClr val="16A34A"/>
-                </a:solidFill>
-                <a:latin typeface="Segoe UI"/>
-              </a:rPr>
-              <a:t>📷 WITH OUR AI:</a:t>
-            </a:r>
-          </a:p>
-        </p:txBody>
-      </p:sp>
-      <p:sp>
-        <p:nvSpPr>
-          <p:cNvPr id="15" name="TextBox 14"/>
-          <p:cNvSpPr txBox="1"/>
-          <p:nvPr/>
-        </p:nvSpPr>
-        <p:spPr>
-          <a:xfrm>
-            <a:off x="6126480" y="2057400"/>
-            <a:ext cx="5394960" cy="256032"/>
-          </a:xfrm>
-          <a:prstGeom prst="rect">
-            <a:avLst/>
-          </a:prstGeom>
-          <a:noFill/>
-        </p:spPr>
-        <p:txBody>
-          <a:bodyPr wrap="square" lIns="0" rIns="0" tIns="0" bIns="0" anchor="t">
-            <a:spAutoFit/>
-          </a:bodyPr>
-          <a:lstStyle/>
-          <a:p>
-            <a:pPr algn="l"/>
-            <a:r>
               <a:rPr sz="1000" b="0">
                 <a:solidFill>
                   <a:srgbClr val="1E293B"/>
                 </a:solidFill>
                 <a:latin typeface="Segoe UI"/>
               </a:rPr>
-              <a:t>Patient uploads photo → Claude READS it → extracts all values → interprets them instantly.</a:t>
+              <a:t>AI reads the photo
+→ Extracts all values instantly</a:t>
             </a:r>
           </a:p>
         </p:txBody>
@@ -15627,8 +15629,8 @@
         </p:nvSpPr>
         <p:spPr>
           <a:xfrm>
-            <a:off x="457200" y="2468880"/>
-            <a:ext cx="5303520" cy="594360"/>
+            <a:off x="457200" y="3063239"/>
+            <a:ext cx="5577840" cy="777240"/>
           </a:xfrm>
           <a:prstGeom prst="roundRect">
             <a:avLst>
@@ -15674,8 +15676,8 @@
         </p:nvSpPr>
         <p:spPr>
           <a:xfrm>
-            <a:off x="640080" y="2542032"/>
-            <a:ext cx="5029200" cy="256032"/>
+            <a:off x="640080" y="3154679"/>
+            <a:ext cx="5212080" cy="640080"/>
           </a:xfrm>
           <a:prstGeom prst="rect">
             <a:avLst/>
@@ -15690,62 +15692,28 @@
           <a:p>
             <a:pPr algn="l"/>
             <a:r>
-              <a:rPr sz="900" b="1">
-                <a:solidFill>
-                  <a:srgbClr val="DC2626"/>
-                </a:solidFill>
-                <a:latin typeface="Segoe UI"/>
-              </a:rPr>
-              <a:t>❌  WITHOUT AI:</a:t>
-            </a:r>
-          </a:p>
-        </p:txBody>
-      </p:sp>
-      <p:sp>
-        <p:nvSpPr>
-          <p:cNvPr id="18" name="TextBox 17"/>
-          <p:cNvSpPr txBox="1"/>
-          <p:nvPr/>
-        </p:nvSpPr>
-        <p:spPr>
-          <a:xfrm>
-            <a:off x="640080" y="2788920"/>
-            <a:ext cx="5029200" cy="256032"/>
-          </a:xfrm>
-          <a:prstGeom prst="rect">
-            <a:avLst/>
-          </a:prstGeom>
-          <a:noFill/>
-        </p:spPr>
-        <p:txBody>
-          <a:bodyPr wrap="square" lIns="0" rIns="0" tIns="0" bIns="0" anchor="t">
-            <a:spAutoFit/>
-          </a:bodyPr>
-          <a:lstStyle/>
-          <a:p>
-            <a:pPr algn="l"/>
-            <a:r>
               <a:rPr sz="1000" b="0">
                 <a:solidFill>
                   <a:srgbClr val="1E293B"/>
                 </a:solidFill>
                 <a:latin typeface="Segoe UI"/>
               </a:rPr>
-              <a:t>Patient types 'sugar was 245 after dinner' → app stores a number.</a:t>
-            </a:r>
-          </a:p>
-        </p:txBody>
-      </p:sp>
-      <p:sp>
-        <p:nvSpPr>
-          <p:cNvPr id="19" name="Rounded Rectangle 18"/>
+              <a:t>Sugar was 245 after dinner
+→ App stores the number 245</a:t>
+            </a:r>
+          </a:p>
+        </p:txBody>
+      </p:sp>
+      <p:sp>
+        <p:nvSpPr>
+          <p:cNvPr id="18" name="Rounded Rectangle 17"/>
           <p:cNvSpPr/>
           <p:nvPr/>
         </p:nvSpPr>
         <p:spPr>
           <a:xfrm>
-            <a:off x="5943600" y="2468880"/>
-            <a:ext cx="5760720" cy="594360"/>
+            <a:off x="6217920" y="3063239"/>
+            <a:ext cx="5577840" cy="777240"/>
           </a:xfrm>
           <a:prstGeom prst="roundRect">
             <a:avLst>
@@ -15785,14 +15753,14 @@
       </p:sp>
       <p:sp>
         <p:nvSpPr>
-          <p:cNvPr id="20" name="TextBox 19"/>
-          <p:cNvSpPr txBox="1"/>
-          <p:nvPr/>
-        </p:nvSpPr>
-        <p:spPr>
-          <a:xfrm>
-            <a:off x="6126480" y="2542032"/>
-            <a:ext cx="5394960" cy="256032"/>
+          <p:cNvPr id="19" name="TextBox 18"/>
+          <p:cNvSpPr txBox="1"/>
+          <p:nvPr/>
+        </p:nvSpPr>
+        <p:spPr>
+          <a:xfrm>
+            <a:off x="6400800" y="3154679"/>
+            <a:ext cx="5212080" cy="640080"/>
           </a:xfrm>
           <a:prstGeom prst="rect">
             <a:avLst/>
@@ -15807,62 +15775,28 @@
           <a:p>
             <a:pPr algn="l"/>
             <a:r>
-              <a:rPr sz="900" b="1">
-                <a:solidFill>
-                  <a:srgbClr val="16A34A"/>
-                </a:solidFill>
-                <a:latin typeface="Segoe UI"/>
-              </a:rPr>
-              <a:t>🧠 WITH OUR AI:</a:t>
-            </a:r>
-          </a:p>
-        </p:txBody>
-      </p:sp>
-      <p:sp>
-        <p:nvSpPr>
-          <p:cNvPr id="21" name="TextBox 20"/>
-          <p:cNvSpPr txBox="1"/>
-          <p:nvPr/>
-        </p:nvSpPr>
-        <p:spPr>
-          <a:xfrm>
-            <a:off x="6126480" y="2788920"/>
-            <a:ext cx="5394960" cy="256032"/>
-          </a:xfrm>
-          <a:prstGeom prst="rect">
-            <a:avLst/>
-          </a:prstGeom>
-          <a:noFill/>
-        </p:spPr>
-        <p:txBody>
-          <a:bodyPr wrap="square" lIns="0" rIns="0" tIns="0" bIns="0" anchor="t">
-            <a:spAutoFit/>
-          </a:bodyPr>
-          <a:lstStyle/>
-          <a:p>
-            <a:pPr algn="l"/>
-            <a:r>
               <a:rPr sz="1000" b="0">
                 <a:solidFill>
                   <a:srgbClr val="1E293B"/>
                 </a:solidFill>
                 <a:latin typeface="Segoe UI"/>
               </a:rPr>
-              <a:t>AI knows 245 is HIGH, considers their medication, and says what to eat tomorrow.</a:t>
-            </a:r>
-          </a:p>
-        </p:txBody>
-      </p:sp>
-      <p:sp>
-        <p:nvSpPr>
-          <p:cNvPr id="22" name="Rounded Rectangle 21"/>
+              <a:t>Knows 245 is HIGH for this patient
+→ Tells them what to eat next</a:t>
+            </a:r>
+          </a:p>
+        </p:txBody>
+      </p:sp>
+      <p:sp>
+        <p:nvSpPr>
+          <p:cNvPr id="20" name="Rounded Rectangle 19"/>
           <p:cNvSpPr/>
           <p:nvPr/>
         </p:nvSpPr>
         <p:spPr>
           <a:xfrm>
-            <a:off x="457200" y="3200400"/>
-            <a:ext cx="5303520" cy="594360"/>
+            <a:off x="457200" y="3931920"/>
+            <a:ext cx="5577840" cy="777240"/>
           </a:xfrm>
           <a:prstGeom prst="roundRect">
             <a:avLst>
@@ -15902,14 +15836,14 @@
       </p:sp>
       <p:sp>
         <p:nvSpPr>
-          <p:cNvPr id="23" name="TextBox 22"/>
-          <p:cNvSpPr txBox="1"/>
-          <p:nvPr/>
-        </p:nvSpPr>
-        <p:spPr>
-          <a:xfrm>
-            <a:off x="640080" y="3273552"/>
-            <a:ext cx="5029200" cy="256032"/>
+          <p:cNvPr id="21" name="TextBox 20"/>
+          <p:cNvSpPr txBox="1"/>
+          <p:nvPr/>
+        </p:nvSpPr>
+        <p:spPr>
+          <a:xfrm>
+            <a:off x="640080" y="4023359"/>
+            <a:ext cx="5212080" cy="640080"/>
           </a:xfrm>
           <a:prstGeom prst="rect">
             <a:avLst/>
@@ -15924,62 +15858,28 @@
           <a:p>
             <a:pPr algn="l"/>
             <a:r>
-              <a:rPr sz="900" b="1">
-                <a:solidFill>
-                  <a:srgbClr val="DC2626"/>
-                </a:solidFill>
-                <a:latin typeface="Segoe UI"/>
-              </a:rPr>
-              <a:t>❌  WITHOUT AI:</a:t>
-            </a:r>
-          </a:p>
-        </p:txBody>
-      </p:sp>
-      <p:sp>
-        <p:nvSpPr>
-          <p:cNvPr id="24" name="TextBox 23"/>
-          <p:cNvSpPr txBox="1"/>
-          <p:nvPr/>
-        </p:nvSpPr>
-        <p:spPr>
-          <a:xfrm>
-            <a:off x="640080" y="3520440"/>
-            <a:ext cx="5029200" cy="256032"/>
-          </a:xfrm>
-          <a:prstGeom prst="rect">
-            <a:avLst/>
-          </a:prstGeom>
-          <a:noFill/>
-        </p:spPr>
-        <p:txBody>
-          <a:bodyPr wrap="square" lIns="0" rIns="0" tIns="0" bIns="0" anchor="t">
-            <a:spAutoFit/>
-          </a:bodyPr>
-          <a:lstStyle/>
-          <a:p>
-            <a:pPr algn="l"/>
-            <a:r>
               <a:rPr sz="1000" b="0">
                 <a:solidFill>
                   <a:srgbClr val="1E293B"/>
                 </a:solidFill>
                 <a:latin typeface="Segoe UI"/>
               </a:rPr>
-              <a:t>Doctor sees a table of numbers → must interpret themselves.</a:t>
-            </a:r>
-          </a:p>
-        </p:txBody>
-      </p:sp>
-      <p:sp>
-        <p:nvSpPr>
-          <p:cNvPr id="25" name="Rounded Rectangle 24"/>
+              <a:t>Doctor sees a table of numbers
+→ Must interpret alone</a:t>
+            </a:r>
+          </a:p>
+        </p:txBody>
+      </p:sp>
+      <p:sp>
+        <p:nvSpPr>
+          <p:cNvPr id="22" name="Rounded Rectangle 21"/>
           <p:cNvSpPr/>
           <p:nvPr/>
         </p:nvSpPr>
         <p:spPr>
           <a:xfrm>
-            <a:off x="5943600" y="3200400"/>
-            <a:ext cx="5760720" cy="594360"/>
+            <a:off x="6217920" y="3931920"/>
+            <a:ext cx="5577840" cy="777240"/>
           </a:xfrm>
           <a:prstGeom prst="roundRect">
             <a:avLst>
@@ -16019,14 +15919,14 @@
       </p:sp>
       <p:sp>
         <p:nvSpPr>
-          <p:cNvPr id="26" name="TextBox 25"/>
-          <p:cNvSpPr txBox="1"/>
-          <p:nvPr/>
-        </p:nvSpPr>
-        <p:spPr>
-          <a:xfrm>
-            <a:off x="6126480" y="3273552"/>
-            <a:ext cx="5394960" cy="256032"/>
+          <p:cNvPr id="23" name="TextBox 22"/>
+          <p:cNvSpPr txBox="1"/>
+          <p:nvPr/>
+        </p:nvSpPr>
+        <p:spPr>
+          <a:xfrm>
+            <a:off x="6400800" y="4023359"/>
+            <a:ext cx="5212080" cy="640080"/>
           </a:xfrm>
           <a:prstGeom prst="rect">
             <a:avLst/>
@@ -16041,62 +15941,28 @@
           <a:p>
             <a:pPr algn="l"/>
             <a:r>
-              <a:rPr sz="900" b="1">
-                <a:solidFill>
-                  <a:srgbClr val="16A34A"/>
-                </a:solidFill>
-                <a:latin typeface="Segoe UI"/>
-              </a:rPr>
-              <a:t>📊 WITH OUR AI:</a:t>
-            </a:r>
-          </a:p>
-        </p:txBody>
-      </p:sp>
-      <p:sp>
-        <p:nvSpPr>
-          <p:cNvPr id="27" name="TextBox 26"/>
-          <p:cNvSpPr txBox="1"/>
-          <p:nvPr/>
-        </p:nvSpPr>
-        <p:spPr>
-          <a:xfrm>
-            <a:off x="6126480" y="3520440"/>
-            <a:ext cx="5394960" cy="256032"/>
-          </a:xfrm>
-          <a:prstGeom prst="rect">
-            <a:avLst/>
-          </a:prstGeom>
-          <a:noFill/>
-        </p:spPr>
-        <p:txBody>
-          <a:bodyPr wrap="square" lIns="0" rIns="0" tIns="0" bIns="0" anchor="t">
-            <a:spAutoFit/>
-          </a:bodyPr>
-          <a:lstStyle/>
-          <a:p>
-            <a:pPr algn="l"/>
-            <a:r>
               <a:rPr sz="1000" b="0">
                 <a:solidFill>
                   <a:srgbClr val="1E293B"/>
                 </a:solidFill>
                 <a:latin typeface="Segoe UI"/>
               </a:rPr>
-              <a:t>AI says 'HbA1c trending down but LDL rising — recommend statin discussion.'</a:t>
-            </a:r>
-          </a:p>
-        </p:txBody>
-      </p:sp>
-      <p:sp>
-        <p:nvSpPr>
-          <p:cNvPr id="28" name="Rounded Rectangle 27"/>
+              <a:t>AI says: HbA1c dropping but LDL rising
+→ Recommend statin discussion</a:t>
+            </a:r>
+          </a:p>
+        </p:txBody>
+      </p:sp>
+      <p:sp>
+        <p:nvSpPr>
+          <p:cNvPr id="24" name="Rounded Rectangle 23"/>
           <p:cNvSpPr/>
           <p:nvPr/>
         </p:nvSpPr>
         <p:spPr>
           <a:xfrm>
-            <a:off x="457200" y="3931920"/>
-            <a:ext cx="5303520" cy="594360"/>
+            <a:off x="457200" y="4800600"/>
+            <a:ext cx="5577840" cy="777240"/>
           </a:xfrm>
           <a:prstGeom prst="roundRect">
             <a:avLst>
@@ -16136,14 +16002,14 @@
       </p:sp>
       <p:sp>
         <p:nvSpPr>
-          <p:cNvPr id="29" name="TextBox 28"/>
-          <p:cNvSpPr txBox="1"/>
-          <p:nvPr/>
-        </p:nvSpPr>
-        <p:spPr>
-          <a:xfrm>
-            <a:off x="640080" y="4005072"/>
-            <a:ext cx="5029200" cy="256032"/>
+          <p:cNvPr id="25" name="TextBox 24"/>
+          <p:cNvSpPr txBox="1"/>
+          <p:nvPr/>
+        </p:nvSpPr>
+        <p:spPr>
+          <a:xfrm>
+            <a:off x="640080" y="4892040"/>
+            <a:ext cx="5212080" cy="640080"/>
           </a:xfrm>
           <a:prstGeom prst="rect">
             <a:avLst/>
@@ -16158,62 +16024,28 @@
           <a:p>
             <a:pPr algn="l"/>
             <a:r>
-              <a:rPr sz="900" b="1">
-                <a:solidFill>
-                  <a:srgbClr val="DC2626"/>
-                </a:solidFill>
-                <a:latin typeface="Segoe UI"/>
-              </a:rPr>
-              <a:t>❌  WITHOUT AI:</a:t>
-            </a:r>
-          </a:p>
-        </p:txBody>
-      </p:sp>
-      <p:sp>
-        <p:nvSpPr>
-          <p:cNvPr id="30" name="TextBox 29"/>
-          <p:cNvSpPr txBox="1"/>
-          <p:nvPr/>
-        </p:nvSpPr>
-        <p:spPr>
-          <a:xfrm>
-            <a:off x="640080" y="4251959"/>
-            <a:ext cx="5029200" cy="256032"/>
-          </a:xfrm>
-          <a:prstGeom prst="rect">
-            <a:avLst/>
-          </a:prstGeom>
-          <a:noFill/>
-        </p:spPr>
-        <p:txBody>
-          <a:bodyPr wrap="square" lIns="0" rIns="0" tIns="0" bIns="0" anchor="t">
-            <a:spAutoFit/>
-          </a:bodyPr>
-          <a:lstStyle/>
-          <a:p>
-            <a:pPr algn="l"/>
-            <a:r>
               <a:rPr sz="1000" b="0">
                 <a:solidFill>
                   <a:srgbClr val="1E293B"/>
                 </a:solidFill>
                 <a:latin typeface="Segoe UI"/>
               </a:rPr>
-              <a:t>Patient asks 'can I eat nasi lemak?' → generic meal plan PDF.</a:t>
-            </a:r>
-          </a:p>
-        </p:txBody>
-      </p:sp>
-      <p:sp>
-        <p:nvSpPr>
-          <p:cNvPr id="31" name="Rounded Rectangle 30"/>
+              <a:t>Can I eat nasi lemak?
+→ Generic PDF advice</a:t>
+            </a:r>
+          </a:p>
+        </p:txBody>
+      </p:sp>
+      <p:sp>
+        <p:nvSpPr>
+          <p:cNvPr id="26" name="Rounded Rectangle 25"/>
           <p:cNvSpPr/>
           <p:nvPr/>
         </p:nvSpPr>
         <p:spPr>
           <a:xfrm>
-            <a:off x="5943600" y="3931920"/>
-            <a:ext cx="5760720" cy="594360"/>
+            <a:off x="6217920" y="4800600"/>
+            <a:ext cx="5577840" cy="777240"/>
           </a:xfrm>
           <a:prstGeom prst="roundRect">
             <a:avLst>
@@ -16253,14 +16085,14 @@
       </p:sp>
       <p:sp>
         <p:nvSpPr>
-          <p:cNvPr id="32" name="TextBox 31"/>
-          <p:cNvSpPr txBox="1"/>
-          <p:nvPr/>
-        </p:nvSpPr>
-        <p:spPr>
-          <a:xfrm>
-            <a:off x="6126480" y="4005072"/>
-            <a:ext cx="5394960" cy="256032"/>
+          <p:cNvPr id="27" name="TextBox 26"/>
+          <p:cNvSpPr txBox="1"/>
+          <p:nvPr/>
+        </p:nvSpPr>
+        <p:spPr>
+          <a:xfrm>
+            <a:off x="6400800" y="4892040"/>
+            <a:ext cx="5212080" cy="640080"/>
           </a:xfrm>
           <a:prstGeom prst="rect">
             <a:avLst/>
@@ -16275,62 +16107,28 @@
           <a:p>
             <a:pPr algn="l"/>
             <a:r>
-              <a:rPr sz="900" b="1">
-                <a:solidFill>
-                  <a:srgbClr val="16A34A"/>
-                </a:solidFill>
-                <a:latin typeface="Segoe UI"/>
-              </a:rPr>
-              <a:t>🥗 WITH OUR AI:</a:t>
-            </a:r>
-          </a:p>
-        </p:txBody>
-      </p:sp>
-      <p:sp>
-        <p:nvSpPr>
-          <p:cNvPr id="33" name="TextBox 32"/>
-          <p:cNvSpPr txBox="1"/>
-          <p:nvPr/>
-        </p:nvSpPr>
-        <p:spPr>
-          <a:xfrm>
-            <a:off x="6126480" y="4251959"/>
-            <a:ext cx="5394960" cy="256032"/>
-          </a:xfrm>
-          <a:prstGeom prst="rect">
-            <a:avLst/>
-          </a:prstGeom>
-          <a:noFill/>
-        </p:spPr>
-        <p:txBody>
-          <a:bodyPr wrap="square" lIns="0" rIns="0" tIns="0" bIns="0" anchor="t">
-            <a:spAutoFit/>
-          </a:bodyPr>
-          <a:lstStyle/>
-          <a:p>
-            <a:pPr algn="l"/>
-            <a:r>
               <a:rPr sz="1000" b="0">
                 <a:solidFill>
                   <a:srgbClr val="1E293B"/>
                 </a:solidFill>
                 <a:latin typeface="Segoe UI"/>
               </a:rPr>
-              <a:t>AI knows their HbA1c, weight, meds → suggests HALF rice + extra egg + teh-o kosong.</a:t>
-            </a:r>
-          </a:p>
-        </p:txBody>
-      </p:sp>
-      <p:sp>
-        <p:nvSpPr>
-          <p:cNvPr id="34" name="Rounded Rectangle 33"/>
+              <a:t>Knows their weight, meds, HbA1c
+→ Half rice + extra egg + teh-o</a:t>
+            </a:r>
+          </a:p>
+        </p:txBody>
+      </p:sp>
+      <p:sp>
+        <p:nvSpPr>
+          <p:cNvPr id="28" name="Rounded Rectangle 27"/>
           <p:cNvSpPr/>
           <p:nvPr/>
         </p:nvSpPr>
         <p:spPr>
           <a:xfrm>
-            <a:off x="457200" y="4663440"/>
-            <a:ext cx="5303520" cy="594360"/>
+            <a:off x="457200" y="5669280"/>
+            <a:ext cx="5577840" cy="777240"/>
           </a:xfrm>
           <a:prstGeom prst="roundRect">
             <a:avLst>
@@ -16370,14 +16168,14 @@
       </p:sp>
       <p:sp>
         <p:nvSpPr>
-          <p:cNvPr id="35" name="TextBox 34"/>
-          <p:cNvSpPr txBox="1"/>
-          <p:nvPr/>
-        </p:nvSpPr>
-        <p:spPr>
-          <a:xfrm>
-            <a:off x="640080" y="4736592"/>
-            <a:ext cx="5029200" cy="256032"/>
+          <p:cNvPr id="29" name="TextBox 28"/>
+          <p:cNvSpPr txBox="1"/>
+          <p:nvPr/>
+        </p:nvSpPr>
+        <p:spPr>
+          <a:xfrm>
+            <a:off x="640080" y="5760720"/>
+            <a:ext cx="5212080" cy="640080"/>
           </a:xfrm>
           <a:prstGeom prst="rect">
             <a:avLst/>
@@ -16392,62 +16190,28 @@
           <a:p>
             <a:pPr algn="l"/>
             <a:r>
-              <a:rPr sz="900" b="1">
-                <a:solidFill>
-                  <a:srgbClr val="DC2626"/>
-                </a:solidFill>
-                <a:latin typeface="Segoe UI"/>
-              </a:rPr>
-              <a:t>❌  WITHOUT AI:</a:t>
-            </a:r>
-          </a:p>
-        </p:txBody>
-      </p:sp>
-      <p:sp>
-        <p:nvSpPr>
-          <p:cNvPr id="36" name="TextBox 35"/>
-          <p:cNvSpPr txBox="1"/>
-          <p:nvPr/>
-        </p:nvSpPr>
-        <p:spPr>
-          <a:xfrm>
-            <a:off x="640080" y="4983479"/>
-            <a:ext cx="5029200" cy="256032"/>
-          </a:xfrm>
-          <a:prstGeom prst="rect">
-            <a:avLst/>
-          </a:prstGeom>
-          <a:noFill/>
-        </p:spPr>
-        <p:txBody>
-          <a:bodyPr wrap="square" lIns="0" rIns="0" tIns="0" bIns="0" anchor="t">
-            <a:spAutoFit/>
-          </a:bodyPr>
-          <a:lstStyle/>
-          <a:p>
-            <a:pPr algn="l"/>
-            <a:r>
               <a:rPr sz="1000" b="0">
                 <a:solidFill>
                   <a:srgbClr val="1E293B"/>
                 </a:solidFill>
                 <a:latin typeface="Segoe UI"/>
               </a:rPr>
-              <a:t>Risk detection: none until next clinic visit in 3 months.</a:t>
-            </a:r>
-          </a:p>
-        </p:txBody>
-      </p:sp>
-      <p:sp>
-        <p:nvSpPr>
-          <p:cNvPr id="37" name="Rounded Rectangle 36"/>
+              <a:t>Risk detection
+→ Nothing until next visit (3 months)</a:t>
+            </a:r>
+          </a:p>
+        </p:txBody>
+      </p:sp>
+      <p:sp>
+        <p:nvSpPr>
+          <p:cNvPr id="30" name="Rounded Rectangle 29"/>
           <p:cNvSpPr/>
           <p:nvPr/>
         </p:nvSpPr>
         <p:spPr>
           <a:xfrm>
-            <a:off x="5943600" y="4663440"/>
-            <a:ext cx="5760720" cy="594360"/>
+            <a:off x="6217920" y="5669280"/>
+            <a:ext cx="5577840" cy="777240"/>
           </a:xfrm>
           <a:prstGeom prst="roundRect">
             <a:avLst>
@@ -16487,14 +16251,14 @@
       </p:sp>
       <p:sp>
         <p:nvSpPr>
-          <p:cNvPr id="38" name="TextBox 37"/>
-          <p:cNvSpPr txBox="1"/>
-          <p:nvPr/>
-        </p:nvSpPr>
-        <p:spPr>
-          <a:xfrm>
-            <a:off x="6126480" y="4736592"/>
-            <a:ext cx="5394960" cy="256032"/>
+          <p:cNvPr id="31" name="TextBox 30"/>
+          <p:cNvSpPr txBox="1"/>
+          <p:nvPr/>
+        </p:nvSpPr>
+        <p:spPr>
+          <a:xfrm>
+            <a:off x="6400800" y="5760720"/>
+            <a:ext cx="5212080" cy="640080"/>
           </a:xfrm>
           <a:prstGeom prst="rect">
             <a:avLst/>
@@ -16509,324 +16273,56 @@
           <a:p>
             <a:pPr algn="l"/>
             <a:r>
-              <a:rPr sz="900" b="1">
-                <a:solidFill>
-                  <a:srgbClr val="16A34A"/>
-                </a:solidFill>
-                <a:latin typeface="Segoe UI"/>
-              </a:rPr>
-              <a:t>⚡ WITH OUR AI:</a:t>
-            </a:r>
-          </a:p>
-        </p:txBody>
-      </p:sp>
-      <p:sp>
-        <p:nvSpPr>
-          <p:cNvPr id="39" name="TextBox 38"/>
-          <p:cNvSpPr txBox="1"/>
-          <p:nvPr/>
-        </p:nvSpPr>
-        <p:spPr>
-          <a:xfrm>
-            <a:off x="6126480" y="4983479"/>
-            <a:ext cx="5394960" cy="256032"/>
-          </a:xfrm>
-          <a:prstGeom prst="rect">
-            <a:avLst/>
-          </a:prstGeom>
-          <a:noFill/>
-        </p:spPr>
-        <p:txBody>
-          <a:bodyPr wrap="square" lIns="0" rIns="0" tIns="0" bIns="0" anchor="t">
-            <a:spAutoFit/>
-          </a:bodyPr>
-          <a:lstStyle/>
-          <a:p>
-            <a:pPr algn="l"/>
-            <a:r>
               <a:rPr sz="1000" b="0">
                 <a:solidFill>
                   <a:srgbClr val="1E293B"/>
                 </a:solidFill>
                 <a:latin typeface="Segoe UI"/>
               </a:rPr>
-              <a:t>AI flags: 'Gap &gt;6h between meals + on glimepiride = hypoglycemia risk RIGHT NOW.'</a:t>
-            </a:r>
-          </a:p>
-        </p:txBody>
-      </p:sp>
-      <p:sp>
-        <p:nvSpPr>
-          <p:cNvPr id="40" name="Rounded Rectangle 39"/>
-          <p:cNvSpPr/>
-          <p:nvPr/>
-        </p:nvSpPr>
-        <p:spPr>
-          <a:xfrm>
-            <a:off x="457200" y="5394960"/>
-            <a:ext cx="5303520" cy="594360"/>
-          </a:xfrm>
-          <a:prstGeom prst="roundRect">
-            <a:avLst>
-              <a:gd name="adj" fmla="val 4000"/>
-            </a:avLst>
-          </a:prstGeom>
-          <a:solidFill>
-            <a:srgbClr val="FEE2E2"/>
-          </a:solidFill>
-          <a:ln w="9525">
-            <a:solidFill>
-              <a:srgbClr val="DC2626"/>
-            </a:solidFill>
-          </a:ln>
-        </p:spPr>
-        <p:style>
-          <a:lnRef idx="1">
-            <a:schemeClr val="accent1"/>
-          </a:lnRef>
-          <a:fillRef idx="3">
-            <a:schemeClr val="accent1"/>
-          </a:fillRef>
-          <a:effectRef idx="2">
-            <a:schemeClr val="accent1"/>
-          </a:effectRef>
-          <a:fontRef idx="minor">
-            <a:schemeClr val="lt1"/>
-          </a:fontRef>
-        </p:style>
-        <p:txBody>
-          <a:bodyPr rtlCol="0" anchor="ctr"/>
+              <a:t>Flags: meal gap + medication
+→ Hypo risk RIGHT NOW</a:t>
+            </a:r>
+          </a:p>
+        </p:txBody>
+      </p:sp>
+      <p:sp>
+        <p:nvSpPr>
+          <p:cNvPr id="32" name="TextBox 31"/>
+          <p:cNvSpPr txBox="1"/>
+          <p:nvPr/>
+        </p:nvSpPr>
+        <p:spPr>
+          <a:xfrm>
+            <a:off x="457200" y="6400800"/>
+            <a:ext cx="11247120" cy="274320"/>
+          </a:xfrm>
+          <a:prstGeom prst="rect">
+            <a:avLst/>
+          </a:prstGeom>
+          <a:noFill/>
+        </p:spPr>
+        <p:txBody>
+          <a:bodyPr wrap="square" lIns="0" rIns="0" tIns="0" bIns="0" anchor="t">
+            <a:spAutoFit/>
+          </a:bodyPr>
           <a:lstStyle/>
           <a:p>
             <a:pPr algn="ctr"/>
-          </a:p>
-        </p:txBody>
-      </p:sp>
-      <p:sp>
-        <p:nvSpPr>
-          <p:cNvPr id="41" name="TextBox 40"/>
-          <p:cNvSpPr txBox="1"/>
-          <p:nvPr/>
-        </p:nvSpPr>
-        <p:spPr>
-          <a:xfrm>
-            <a:off x="640080" y="5468112"/>
-            <a:ext cx="5029200" cy="256032"/>
-          </a:xfrm>
-          <a:prstGeom prst="rect">
-            <a:avLst/>
-          </a:prstGeom>
-          <a:noFill/>
-        </p:spPr>
-        <p:txBody>
-          <a:bodyPr wrap="square" lIns="0" rIns="0" tIns="0" bIns="0" anchor="t">
-            <a:spAutoFit/>
-          </a:bodyPr>
-          <a:lstStyle/>
-          <a:p>
-            <a:pPr algn="l"/>
-            <a:r>
-              <a:rPr sz="900" b="1">
-                <a:solidFill>
-                  <a:srgbClr val="DC2626"/>
-                </a:solidFill>
-                <a:latin typeface="Segoe UI"/>
-              </a:rPr>
-              <a:t>❌  WITHOUT AI:</a:t>
-            </a:r>
-          </a:p>
-        </p:txBody>
-      </p:sp>
-      <p:sp>
-        <p:nvSpPr>
-          <p:cNvPr id="42" name="TextBox 41"/>
-          <p:cNvSpPr txBox="1"/>
-          <p:nvPr/>
-        </p:nvSpPr>
-        <p:spPr>
-          <a:xfrm>
-            <a:off x="640080" y="5715000"/>
-            <a:ext cx="5029200" cy="256032"/>
-          </a:xfrm>
-          <a:prstGeom prst="rect">
-            <a:avLst/>
-          </a:prstGeom>
-          <a:noFill/>
-        </p:spPr>
-        <p:txBody>
-          <a:bodyPr wrap="square" lIns="0" rIns="0" tIns="0" bIns="0" anchor="t">
-            <a:spAutoFit/>
-          </a:bodyPr>
-          <a:lstStyle/>
-          <a:p>
-            <a:pPr algn="l"/>
             <a:r>
               <a:rPr sz="1000" b="0">
                 <a:solidFill>
-                  <a:srgbClr val="1E293B"/>
-                </a:solidFill>
-                <a:latin typeface="Segoe UI"/>
-              </a:rPr>
-              <a:t>Email reports: copy-paste from app.</a:t>
-            </a:r>
-          </a:p>
-        </p:txBody>
-      </p:sp>
-      <p:sp>
-        <p:nvSpPr>
-          <p:cNvPr id="43" name="Rounded Rectangle 42"/>
-          <p:cNvSpPr/>
-          <p:nvPr/>
-        </p:nvSpPr>
-        <p:spPr>
-          <a:xfrm>
-            <a:off x="5943600" y="5394960"/>
-            <a:ext cx="5760720" cy="594360"/>
-          </a:xfrm>
-          <a:prstGeom prst="roundRect">
-            <a:avLst>
-              <a:gd name="adj" fmla="val 4000"/>
-            </a:avLst>
-          </a:prstGeom>
-          <a:solidFill>
-            <a:srgbClr val="DCFCE7"/>
-          </a:solidFill>
-          <a:ln w="9525">
-            <a:solidFill>
-              <a:srgbClr val="16A34A"/>
-            </a:solidFill>
-          </a:ln>
-        </p:spPr>
-        <p:style>
-          <a:lnRef idx="1">
-            <a:schemeClr val="accent1"/>
-          </a:lnRef>
-          <a:fillRef idx="3">
-            <a:schemeClr val="accent1"/>
-          </a:fillRef>
-          <a:effectRef idx="2">
-            <a:schemeClr val="accent1"/>
-          </a:effectRef>
-          <a:fontRef idx="minor">
-            <a:schemeClr val="lt1"/>
-          </a:fontRef>
-        </p:style>
-        <p:txBody>
-          <a:bodyPr rtlCol="0" anchor="ctr"/>
-          <a:lstStyle/>
-          <a:p>
-            <a:pPr algn="ctr"/>
-          </a:p>
-        </p:txBody>
-      </p:sp>
-      <p:sp>
-        <p:nvSpPr>
-          <p:cNvPr id="44" name="TextBox 43"/>
-          <p:cNvSpPr txBox="1"/>
-          <p:nvPr/>
-        </p:nvSpPr>
-        <p:spPr>
-          <a:xfrm>
-            <a:off x="6126480" y="5468112"/>
-            <a:ext cx="5394960" cy="256032"/>
-          </a:xfrm>
-          <a:prstGeom prst="rect">
-            <a:avLst/>
-          </a:prstGeom>
-          <a:noFill/>
-        </p:spPr>
-        <p:txBody>
-          <a:bodyPr wrap="square" lIns="0" rIns="0" tIns="0" bIns="0" anchor="t">
-            <a:spAutoFit/>
-          </a:bodyPr>
-          <a:lstStyle/>
-          <a:p>
-            <a:pPr algn="l"/>
-            <a:r>
-              <a:rPr sz="900" b="1">
-                <a:solidFill>
-                  <a:srgbClr val="16A34A"/>
-                </a:solidFill>
-                <a:latin typeface="Segoe UI"/>
-              </a:rPr>
-              <a:t>📧 WITH OUR AI:</a:t>
-            </a:r>
-          </a:p>
-        </p:txBody>
-      </p:sp>
-      <p:sp>
-        <p:nvSpPr>
-          <p:cNvPr id="45" name="TextBox 44"/>
-          <p:cNvSpPr txBox="1"/>
-          <p:nvPr/>
-        </p:nvSpPr>
-        <p:spPr>
-          <a:xfrm>
-            <a:off x="6126480" y="5715000"/>
-            <a:ext cx="5394960" cy="256032"/>
-          </a:xfrm>
-          <a:prstGeom prst="rect">
-            <a:avLst/>
-          </a:prstGeom>
-          <a:noFill/>
-        </p:spPr>
-        <p:txBody>
-          <a:bodyPr wrap="square" lIns="0" rIns="0" tIns="0" bIns="0" anchor="t">
-            <a:spAutoFit/>
-          </a:bodyPr>
-          <a:lstStyle/>
-          <a:p>
-            <a:pPr algn="l"/>
-            <a:r>
-              <a:rPr sz="1000" b="0">
-                <a:solidFill>
-                  <a:srgbClr val="1E293B"/>
-                </a:solidFill>
-                <a:latin typeface="Segoe UI"/>
-              </a:rPr>
-              <a:t>One-click: formatted report with charts, insights, and recommendations sent to inbox.</a:t>
-            </a:r>
-          </a:p>
-        </p:txBody>
-      </p:sp>
-      <p:sp>
-        <p:nvSpPr>
-          <p:cNvPr id="46" name="TextBox 45"/>
-          <p:cNvSpPr txBox="1"/>
-          <p:nvPr/>
-        </p:nvSpPr>
-        <p:spPr>
-          <a:xfrm>
-            <a:off x="457200" y="6217920"/>
-            <a:ext cx="11247120" cy="365760"/>
-          </a:xfrm>
-          <a:prstGeom prst="rect">
-            <a:avLst/>
-          </a:prstGeom>
-          <a:noFill/>
-        </p:spPr>
-        <p:txBody>
-          <a:bodyPr wrap="square" lIns="0" rIns="0" tIns="0" bIns="0" anchor="t">
-            <a:spAutoFit/>
-          </a:bodyPr>
-          <a:lstStyle/>
-          <a:p>
-            <a:pPr algn="ctr"/>
-            <a:r>
-              <a:rPr sz="1100" b="1">
-                <a:solidFill>
-                  <a:srgbClr val="16A34A"/>
-                </a:solidFill>
-                <a:latin typeface="Segoe UI"/>
-              </a:rPr>
-              <a:t>Key tech: Amazon Bedrock (Claude 3 Haiku) · Amazon Textract (OCR) · Comprehend Medical (NLP) · Polly (voice)</a:t>
-            </a:r>
-          </a:p>
-        </p:txBody>
-      </p:sp>
-      <p:sp>
-        <p:nvSpPr>
-          <p:cNvPr id="47" name="TextBox 46"/>
+                  <a:srgbClr val="64748B"/>
+                </a:solidFill>
+                <a:latin typeface="Segoe UI"/>
+              </a:rPr>
+              <a:t>Powered by: Amazon Bedrock (Claude 3 Haiku) + Textract + Comprehend Medical + Polly</a:t>
+            </a:r>
+          </a:p>
+        </p:txBody>
+      </p:sp>
+      <p:sp>
+        <p:nvSpPr>
+          <p:cNvPr id="33" name="TextBox 32"/>
           <p:cNvSpPr txBox="1"/>
           <p:nvPr/>
         </p:nvSpPr>

</xml_diff>

<commit_message>
Slide 9: add Encik Razak patient scenario showing before/after impact
</commit_message>
<xml_diff>
--- a/presentation/DiabetesControl_AI_v5.pptx
+++ b/presentation/DiabetesControl_AI_v5.pptx
@@ -16604,7 +16604,7 @@
                 </a:solidFill>
                 <a:latin typeface="Segoe UI"/>
               </a:rPr>
-              <a:t>Impact &amp; Sustainability</a:t>
+              <a:t>Real-World Impact</a:t>
             </a:r>
           </a:p>
         </p:txBody>
@@ -16639,7 +16639,7 @@
                 </a:solidFill>
                 <a:latin typeface="Segoe UI"/>
               </a:rPr>
-              <a:t>Real Impact, Real Numbers</a:t>
+              <a:t>How It Changes One Life</a:t>
             </a:r>
           </a:p>
         </p:txBody>
@@ -16652,8 +16652,8 @@
         </p:nvSpPr>
         <p:spPr>
           <a:xfrm>
-            <a:off x="457200" y="1371600"/>
-            <a:ext cx="5623560" cy="2286000"/>
+            <a:off x="457200" y="1280160"/>
+            <a:ext cx="11247120" cy="2377440"/>
           </a:xfrm>
           <a:prstGeom prst="roundRect">
             <a:avLst>
@@ -16699,7 +16699,42 @@
         </p:nvSpPr>
         <p:spPr>
           <a:xfrm>
-            <a:off x="640080" y="1508760"/>
+            <a:off x="640080" y="1371600"/>
+            <a:ext cx="10881360" cy="320040"/>
+          </a:xfrm>
+          <a:prstGeom prst="rect">
+            <a:avLst/>
+          </a:prstGeom>
+          <a:noFill/>
+        </p:spPr>
+        <p:txBody>
+          <a:bodyPr wrap="square" lIns="0" rIns="0" tIns="0" bIns="0" anchor="t">
+            <a:spAutoFit/>
+          </a:bodyPr>
+          <a:lstStyle/>
+          <a:p>
+            <a:pPr algn="l"/>
+            <a:r>
+              <a:rPr sz="1400" b="1">
+                <a:solidFill>
+                  <a:srgbClr val="16A34A"/>
+                </a:solidFill>
+                <a:latin typeface="Segoe UI"/>
+              </a:rPr>
+              <a:t>Encik Razak, 55 — Taxi driver in Petaling Jaya — Type 2 diabetes, 6 years</a:t>
+            </a:r>
+          </a:p>
+        </p:txBody>
+      </p:sp>
+      <p:sp>
+        <p:nvSpPr>
+          <p:cNvPr id="11" name="TextBox 10"/>
+          <p:cNvSpPr txBox="1"/>
+          <p:nvPr/>
+        </p:nvSpPr>
+        <p:spPr>
+          <a:xfrm>
+            <a:off x="640080" y="1737360"/>
             <a:ext cx="5303520" cy="274320"/>
           </a:xfrm>
           <a:prstGeom prst="rect">
@@ -16715,27 +16750,101 @@
           <a:p>
             <a:pPr algn="l"/>
             <a:r>
-              <a:rPr sz="1200" b="1">
+              <a:rPr sz="1100" b="1">
+                <a:solidFill>
+                  <a:srgbClr val="DC2626"/>
+                </a:solidFill>
+                <a:latin typeface="Segoe UI"/>
+              </a:rPr>
+              <a:t>❌  BEFORE (no app):</a:t>
+            </a:r>
+          </a:p>
+        </p:txBody>
+      </p:sp>
+      <p:sp>
+        <p:nvSpPr>
+          <p:cNvPr id="12" name="TextBox 11"/>
+          <p:cNvSpPr txBox="1"/>
+          <p:nvPr/>
+        </p:nvSpPr>
+        <p:spPr>
+          <a:xfrm>
+            <a:off x="640080" y="2011680"/>
+            <a:ext cx="5303520" cy="1371600"/>
+          </a:xfrm>
+          <a:prstGeom prst="rect">
+            <a:avLst/>
+          </a:prstGeom>
+          <a:noFill/>
+        </p:spPr>
+        <p:txBody>
+          <a:bodyPr wrap="square" lIns="0" rIns="0" tIns="0" bIns="0" anchor="t">
+            <a:spAutoFit/>
+          </a:bodyPr>
+          <a:lstStyle/>
+          <a:p>
+            <a:pPr algn="l"/>
+            <a:r>
+              <a:rPr sz="1000" b="0">
+                <a:solidFill>
+                  <a:srgbClr val="1E293B"/>
+                </a:solidFill>
+                <a:latin typeface="Segoe UI"/>
+              </a:rPr>
+              <a:t>• Eats nasi lemak every morning, sugar spikes to 240
+• Doesn't know which foods are safe
+• Next specialist appointment: 4 months away
+• Forgot to take medication twice this week
+• HbA1c stuck at 8.2% for 2 years</a:t>
+            </a:r>
+          </a:p>
+        </p:txBody>
+      </p:sp>
+      <p:sp>
+        <p:nvSpPr>
+          <p:cNvPr id="13" name="TextBox 12"/>
+          <p:cNvSpPr txBox="1"/>
+          <p:nvPr/>
+        </p:nvSpPr>
+        <p:spPr>
+          <a:xfrm>
+            <a:off x="6217920" y="1737360"/>
+            <a:ext cx="5303520" cy="274320"/>
+          </a:xfrm>
+          <a:prstGeom prst="rect">
+            <a:avLst/>
+          </a:prstGeom>
+          <a:noFill/>
+        </p:spPr>
+        <p:txBody>
+          <a:bodyPr wrap="square" lIns="0" rIns="0" tIns="0" bIns="0" anchor="t">
+            <a:spAutoFit/>
+          </a:bodyPr>
+          <a:lstStyle/>
+          <a:p>
+            <a:pPr algn="l"/>
+            <a:r>
+              <a:rPr sz="1100" b="1">
                 <a:solidFill>
                   <a:srgbClr val="16A34A"/>
                 </a:solidFill>
                 <a:latin typeface="Segoe UI"/>
               </a:rPr>
-              <a:t>🏥 Ready to Pilot</a:t>
-            </a:r>
-          </a:p>
-        </p:txBody>
-      </p:sp>
-      <p:sp>
-        <p:nvSpPr>
-          <p:cNvPr id="11" name="TextBox 10"/>
-          <p:cNvSpPr txBox="1"/>
-          <p:nvPr/>
-        </p:nvSpPr>
-        <p:spPr>
-          <a:xfrm>
-            <a:off x="640080" y="1828800"/>
-            <a:ext cx="5303520" cy="365760"/>
+              <a:t>✅  AFTER (with our app):</a:t>
+            </a:r>
+          </a:p>
+        </p:txBody>
+      </p:sp>
+      <p:sp>
+        <p:nvSpPr>
+          <p:cNvPr id="14" name="TextBox 13"/>
+          <p:cNvSpPr txBox="1"/>
+          <p:nvPr/>
+        </p:nvSpPr>
+        <p:spPr>
+          <a:xfrm>
+            <a:off x="6217920" y="2011680"/>
+            <a:ext cx="5303520" cy="1371600"/>
           </a:xfrm>
           <a:prstGeom prst="rect">
             <a:avLst/>
@@ -16750,27 +16859,31 @@
           <a:p>
             <a:pPr algn="l"/>
             <a:r>
-              <a:rPr sz="1600" b="1">
+              <a:rPr sz="1000" b="0">
                 <a:solidFill>
                   <a:srgbClr val="1E293B"/>
                 </a:solidFill>
                 <a:latin typeface="Segoe UI"/>
               </a:rPr>
-              <a:t>Klinik Kesihatan Bandar Botanic</a:t>
-            </a:r>
-          </a:p>
-        </p:txBody>
-      </p:sp>
-      <p:sp>
-        <p:nvSpPr>
-          <p:cNvPr id="12" name="TextBox 11"/>
-          <p:cNvSpPr txBox="1"/>
-          <p:nvPr/>
-        </p:nvSpPr>
-        <p:spPr>
-          <a:xfrm>
-            <a:off x="640080" y="2240280"/>
-            <a:ext cx="5303520" cy="640080"/>
+              <a:t>• AI Coach: “Half rice + extra egg + teh-o kosong”
+• Uploads lab photo → AI flags high LDL instantly
+• Sends data to Dr. Sarah → she adjusts plan same day
+• Daily plan reminds medication timing
+• HbA1c drops to 7.4% in 3 months</a:t>
+            </a:r>
+          </a:p>
+        </p:txBody>
+      </p:sp>
+      <p:sp>
+        <p:nvSpPr>
+          <p:cNvPr id="15" name="TextBox 14"/>
+          <p:cNvSpPr txBox="1"/>
+          <p:nvPr/>
+        </p:nvSpPr>
+        <p:spPr>
+          <a:xfrm>
+            <a:off x="640080" y="3337560"/>
+            <a:ext cx="10881360" cy="274320"/>
           </a:xfrm>
           <a:prstGeom prst="rect">
             <a:avLst/>
@@ -16785,65 +16898,27 @@
           <a:p>
             <a:pPr algn="l"/>
             <a:r>
-              <a:rPr sz="1000" b="0">
-                <a:solidFill>
-                  <a:srgbClr val="64748B"/>
-                </a:solidFill>
-                <a:latin typeface="Segoe UI"/>
-              </a:rPr>
-              <a:t>Klang Valley primary care — 1,200 diabetes patients.
-Their endocrinologist sees patients every 3-4 months.
-Our app fills the 90-day gap between visits.</a:t>
-            </a:r>
-          </a:p>
-        </p:txBody>
-      </p:sp>
-      <p:sp>
-        <p:nvSpPr>
-          <p:cNvPr id="13" name="TextBox 12"/>
-          <p:cNvSpPr txBox="1"/>
-          <p:nvPr/>
-        </p:nvSpPr>
-        <p:spPr>
-          <a:xfrm>
-            <a:off x="640080" y="2971800"/>
-            <a:ext cx="5303520" cy="457200"/>
-          </a:xfrm>
-          <a:prstGeom prst="rect">
-            <a:avLst/>
-          </a:prstGeom>
-          <a:noFill/>
-        </p:spPr>
-        <p:txBody>
-          <a:bodyPr wrap="square" lIns="0" rIns="0" tIns="0" bIns="0" anchor="t">
-            <a:spAutoFit/>
-          </a:bodyPr>
-          <a:lstStyle/>
-          <a:p>
-            <a:pPr algn="l"/>
-            <a:r>
-              <a:rPr sz="900" b="1">
-                <a:solidFill>
-                  <a:srgbClr val="16A34A"/>
-                </a:solidFill>
-                <a:latin typeface="Segoe UI"/>
-              </a:rPr>
-              <a:t>Evidence: Cochrane 2025 (updated) confirms
-digital interventions reduce HbA1c by 0.5% average.</a:t>
-            </a:r>
-          </a:p>
-        </p:txBody>
-      </p:sp>
-      <p:sp>
-        <p:nvSpPr>
-          <p:cNvPr id="14" name="Rounded Rectangle 13"/>
+              <a:rPr sz="1100" b="1">
+                <a:solidFill>
+                  <a:srgbClr val="1E293B"/>
+                </a:solidFill>
+                <a:latin typeface="Segoe UI"/>
+              </a:rPr>
+              <a:t>Result: Encik Razak avoids kidney complications, saves RM 2,400/year in hospital visits, and feels in control for the first time.</a:t>
+            </a:r>
+          </a:p>
+        </p:txBody>
+      </p:sp>
+      <p:sp>
+        <p:nvSpPr>
+          <p:cNvPr id="16" name="Rounded Rectangle 15"/>
           <p:cNvSpPr/>
           <p:nvPr/>
         </p:nvSpPr>
         <p:spPr>
           <a:xfrm>
-            <a:off x="6263640" y="1371600"/>
-            <a:ext cx="5440680" cy="2286000"/>
+            <a:off x="457200" y="3840480"/>
+            <a:ext cx="5577840" cy="2468880"/>
           </a:xfrm>
           <a:prstGeom prst="roundRect">
             <a:avLst>
@@ -16883,14 +16958,14 @@
       </p:sp>
       <p:sp>
         <p:nvSpPr>
-          <p:cNvPr id="15" name="TextBox 14"/>
-          <p:cNvSpPr txBox="1"/>
-          <p:nvPr/>
-        </p:nvSpPr>
-        <p:spPr>
-          <a:xfrm>
-            <a:off x="6446520" y="1508760"/>
-            <a:ext cx="5120640" cy="274320"/>
+          <p:cNvPr id="17" name="TextBox 16"/>
+          <p:cNvSpPr txBox="1"/>
+          <p:nvPr/>
+        </p:nvSpPr>
+        <p:spPr>
+          <a:xfrm>
+            <a:off x="640080" y="3931920"/>
+            <a:ext cx="5212080" cy="274320"/>
           </a:xfrm>
           <a:prstGeom prst="rect">
             <a:avLst/>
@@ -16911,21 +16986,21 @@
                 </a:solidFill>
                 <a:latin typeface="Segoe UI"/>
               </a:rPr>
-              <a:t>💰 Cost: $0.13 per user / month</a:t>
-            </a:r>
-          </a:p>
-        </p:txBody>
-      </p:sp>
-      <p:sp>
-        <p:nvSpPr>
-          <p:cNvPr id="16" name="TextBox 15"/>
-          <p:cNvSpPr txBox="1"/>
-          <p:nvPr/>
-        </p:nvSpPr>
-        <p:spPr>
-          <a:xfrm>
-            <a:off x="6446520" y="1920240"/>
-            <a:ext cx="3200400" cy="201168"/>
+              <a:t>🏥  Ready to Pilot</a:t>
+            </a:r>
+          </a:p>
+        </p:txBody>
+      </p:sp>
+      <p:sp>
+        <p:nvSpPr>
+          <p:cNvPr id="18" name="TextBox 17"/>
+          <p:cNvSpPr txBox="1"/>
+          <p:nvPr/>
+        </p:nvSpPr>
+        <p:spPr>
+          <a:xfrm>
+            <a:off x="640080" y="4251960"/>
+            <a:ext cx="5212080" cy="320040"/>
           </a:xfrm>
           <a:prstGeom prst="rect">
             <a:avLst/>
@@ -16940,482 +17015,100 @@
           <a:p>
             <a:pPr algn="l"/>
             <a:r>
+              <a:rPr sz="1400" b="1">
+                <a:solidFill>
+                  <a:srgbClr val="1E293B"/>
+                </a:solidFill>
+                <a:latin typeface="Segoe UI"/>
+              </a:rPr>
+              <a:t>Klinik Kesihatan Bandar Botanic</a:t>
+            </a:r>
+          </a:p>
+        </p:txBody>
+      </p:sp>
+      <p:sp>
+        <p:nvSpPr>
+          <p:cNvPr id="19" name="TextBox 18"/>
+          <p:cNvSpPr txBox="1"/>
+          <p:nvPr/>
+        </p:nvSpPr>
+        <p:spPr>
+          <a:xfrm>
+            <a:off x="640080" y="4617720"/>
+            <a:ext cx="5212080" cy="640080"/>
+          </a:xfrm>
+          <a:prstGeom prst="rect">
+            <a:avLst/>
+          </a:prstGeom>
+          <a:noFill/>
+        </p:spPr>
+        <p:txBody>
+          <a:bodyPr wrap="square" lIns="0" rIns="0" tIns="0" bIns="0" anchor="t">
+            <a:spAutoFit/>
+          </a:bodyPr>
+          <a:lstStyle/>
+          <a:p>
+            <a:pPr algn="l"/>
+            <a:r>
+              <a:rPr sz="1000" b="0">
+                <a:solidFill>
+                  <a:srgbClr val="64748B"/>
+                </a:solidFill>
+                <a:latin typeface="Segoe UI"/>
+              </a:rPr>
+              <a:t>• 1,200 diabetes patients on file
+• Endocrinologist visits every 3-4 months
+• Our app fills the 90-day gap</a:t>
+            </a:r>
+          </a:p>
+        </p:txBody>
+      </p:sp>
+      <p:sp>
+        <p:nvSpPr>
+          <p:cNvPr id="20" name="TextBox 19"/>
+          <p:cNvSpPr txBox="1"/>
+          <p:nvPr/>
+        </p:nvSpPr>
+        <p:spPr>
+          <a:xfrm>
+            <a:off x="640080" y="5394960"/>
+            <a:ext cx="5212080" cy="548640"/>
+          </a:xfrm>
+          <a:prstGeom prst="rect">
+            <a:avLst/>
+          </a:prstGeom>
+          <a:noFill/>
+        </p:spPr>
+        <p:txBody>
+          <a:bodyPr wrap="square" lIns="0" rIns="0" tIns="0" bIns="0" anchor="t">
+            <a:spAutoFit/>
+          </a:bodyPr>
+          <a:lstStyle/>
+          <a:p>
+            <a:pPr algn="l"/>
+            <a:r>
               <a:rPr sz="900" b="0">
                 <a:solidFill>
                   <a:srgbClr val="64748B"/>
                 </a:solidFill>
                 <a:latin typeface="Segoe UI"/>
               </a:rPr>
-              <a:t>Bedrock (200 chats)</a:t>
-            </a:r>
-          </a:p>
-        </p:txBody>
-      </p:sp>
-      <p:sp>
-        <p:nvSpPr>
-          <p:cNvPr id="17" name="TextBox 16"/>
-          <p:cNvSpPr txBox="1"/>
-          <p:nvPr/>
-        </p:nvSpPr>
-        <p:spPr>
-          <a:xfrm>
-            <a:off x="9875520" y="1920240"/>
-            <a:ext cx="1645920" cy="201168"/>
-          </a:xfrm>
-          <a:prstGeom prst="rect">
-            <a:avLst/>
-          </a:prstGeom>
-          <a:noFill/>
-        </p:spPr>
-        <p:txBody>
-          <a:bodyPr wrap="square" lIns="0" rIns="0" tIns="0" bIns="0" anchor="t">
-            <a:spAutoFit/>
-          </a:bodyPr>
-          <a:lstStyle/>
-          <a:p>
-            <a:pPr algn="r"/>
-            <a:r>
-              <a:rPr sz="900" b="0">
-                <a:solidFill>
-                  <a:srgbClr val="1E293B"/>
-                </a:solidFill>
-                <a:latin typeface="Segoe UI"/>
-              </a:rPr>
-              <a:t>$0.10</a:t>
-            </a:r>
-          </a:p>
-        </p:txBody>
-      </p:sp>
-      <p:sp>
-        <p:nvSpPr>
-          <p:cNvPr id="18" name="TextBox 17"/>
-          <p:cNvSpPr txBox="1"/>
-          <p:nvPr/>
-        </p:nvSpPr>
-        <p:spPr>
-          <a:xfrm>
-            <a:off x="6446520" y="2139696"/>
-            <a:ext cx="3200400" cy="201168"/>
-          </a:xfrm>
-          <a:prstGeom prst="rect">
-            <a:avLst/>
-          </a:prstGeom>
-          <a:noFill/>
-        </p:spPr>
-        <p:txBody>
-          <a:bodyPr wrap="square" lIns="0" rIns="0" tIns="0" bIns="0" anchor="t">
-            <a:spAutoFit/>
-          </a:bodyPr>
-          <a:lstStyle/>
-          <a:p>
-            <a:pPr algn="l"/>
-            <a:r>
-              <a:rPr sz="900" b="0">
-                <a:solidFill>
-                  <a:srgbClr val="64748B"/>
-                </a:solidFill>
-                <a:latin typeface="Segoe UI"/>
-              </a:rPr>
-              <a:t>Lambda + API</a:t>
-            </a:r>
-          </a:p>
-        </p:txBody>
-      </p:sp>
-      <p:sp>
-        <p:nvSpPr>
-          <p:cNvPr id="19" name="TextBox 18"/>
-          <p:cNvSpPr txBox="1"/>
-          <p:nvPr/>
-        </p:nvSpPr>
-        <p:spPr>
-          <a:xfrm>
-            <a:off x="9875520" y="2139696"/>
-            <a:ext cx="1645920" cy="201168"/>
-          </a:xfrm>
-          <a:prstGeom prst="rect">
-            <a:avLst/>
-          </a:prstGeom>
-          <a:noFill/>
-        </p:spPr>
-        <p:txBody>
-          <a:bodyPr wrap="square" lIns="0" rIns="0" tIns="0" bIns="0" anchor="t">
-            <a:spAutoFit/>
-          </a:bodyPr>
-          <a:lstStyle/>
-          <a:p>
-            <a:pPr algn="r"/>
-            <a:r>
-              <a:rPr sz="900" b="0">
-                <a:solidFill>
-                  <a:srgbClr val="1E293B"/>
-                </a:solidFill>
-                <a:latin typeface="Segoe UI"/>
-              </a:rPr>
-              <a:t>Free tier</a:t>
-            </a:r>
-          </a:p>
-        </p:txBody>
-      </p:sp>
-      <p:sp>
-        <p:nvSpPr>
-          <p:cNvPr id="20" name="TextBox 19"/>
-          <p:cNvSpPr txBox="1"/>
-          <p:nvPr/>
-        </p:nvSpPr>
-        <p:spPr>
-          <a:xfrm>
-            <a:off x="6446520" y="2359152"/>
-            <a:ext cx="3200400" cy="201168"/>
-          </a:xfrm>
-          <a:prstGeom prst="rect">
-            <a:avLst/>
-          </a:prstGeom>
-          <a:noFill/>
-        </p:spPr>
-        <p:txBody>
-          <a:bodyPr wrap="square" lIns="0" rIns="0" tIns="0" bIns="0" anchor="t">
-            <a:spAutoFit/>
-          </a:bodyPr>
-          <a:lstStyle/>
-          <a:p>
-            <a:pPr algn="l"/>
-            <a:r>
-              <a:rPr sz="900" b="0">
-                <a:solidFill>
-                  <a:srgbClr val="64748B"/>
-                </a:solidFill>
-                <a:latin typeface="Segoe UI"/>
-              </a:rPr>
-              <a:t>DynamoDB (3 tables)</a:t>
-            </a:r>
-          </a:p>
-        </p:txBody>
-      </p:sp>
-      <p:sp>
-        <p:nvSpPr>
-          <p:cNvPr id="21" name="TextBox 20"/>
-          <p:cNvSpPr txBox="1"/>
-          <p:nvPr/>
-        </p:nvSpPr>
-        <p:spPr>
-          <a:xfrm>
-            <a:off x="9875520" y="2359152"/>
-            <a:ext cx="1645920" cy="201168"/>
-          </a:xfrm>
-          <a:prstGeom prst="rect">
-            <a:avLst/>
-          </a:prstGeom>
-          <a:noFill/>
-        </p:spPr>
-        <p:txBody>
-          <a:bodyPr wrap="square" lIns="0" rIns="0" tIns="0" bIns="0" anchor="t">
-            <a:spAutoFit/>
-          </a:bodyPr>
-          <a:lstStyle/>
-          <a:p>
-            <a:pPr algn="r"/>
-            <a:r>
-              <a:rPr sz="900" b="0">
-                <a:solidFill>
-                  <a:srgbClr val="1E293B"/>
-                </a:solidFill>
-                <a:latin typeface="Segoe UI"/>
-              </a:rPr>
-              <a:t>Free tier</a:t>
-            </a:r>
-          </a:p>
-        </p:txBody>
-      </p:sp>
-      <p:sp>
-        <p:nvSpPr>
-          <p:cNvPr id="22" name="TextBox 21"/>
-          <p:cNvSpPr txBox="1"/>
-          <p:nvPr/>
-        </p:nvSpPr>
-        <p:spPr>
-          <a:xfrm>
-            <a:off x="6446520" y="2578608"/>
-            <a:ext cx="3200400" cy="201168"/>
-          </a:xfrm>
-          <a:prstGeom prst="rect">
-            <a:avLst/>
-          </a:prstGeom>
-          <a:noFill/>
-        </p:spPr>
-        <p:txBody>
-          <a:bodyPr wrap="square" lIns="0" rIns="0" tIns="0" bIns="0" anchor="t">
-            <a:spAutoFit/>
-          </a:bodyPr>
-          <a:lstStyle/>
-          <a:p>
-            <a:pPr algn="l"/>
-            <a:r>
-              <a:rPr sz="900" b="0">
-                <a:solidFill>
-                  <a:srgbClr val="64748B"/>
-                </a:solidFill>
-                <a:latin typeface="Segoe UI"/>
-              </a:rPr>
-              <a:t>SES + CloudFront + S3</a:t>
-            </a:r>
-          </a:p>
-        </p:txBody>
-      </p:sp>
-      <p:sp>
-        <p:nvSpPr>
-          <p:cNvPr id="23" name="TextBox 22"/>
-          <p:cNvSpPr txBox="1"/>
-          <p:nvPr/>
-        </p:nvSpPr>
-        <p:spPr>
-          <a:xfrm>
-            <a:off x="9875520" y="2578608"/>
-            <a:ext cx="1645920" cy="201168"/>
-          </a:xfrm>
-          <a:prstGeom prst="rect">
-            <a:avLst/>
-          </a:prstGeom>
-          <a:noFill/>
-        </p:spPr>
-        <p:txBody>
-          <a:bodyPr wrap="square" lIns="0" rIns="0" tIns="0" bIns="0" anchor="t">
-            <a:spAutoFit/>
-          </a:bodyPr>
-          <a:lstStyle/>
-          <a:p>
-            <a:pPr algn="r"/>
-            <a:r>
-              <a:rPr sz="900" b="0">
-                <a:solidFill>
-                  <a:srgbClr val="1E293B"/>
-                </a:solidFill>
-                <a:latin typeface="Segoe UI"/>
-              </a:rPr>
-              <a:t>$0.03</a:t>
-            </a:r>
-          </a:p>
-        </p:txBody>
-      </p:sp>
-      <p:sp>
-        <p:nvSpPr>
-          <p:cNvPr id="24" name="TextBox 23"/>
-          <p:cNvSpPr txBox="1"/>
-          <p:nvPr/>
-        </p:nvSpPr>
-        <p:spPr>
-          <a:xfrm>
-            <a:off x="6446520" y="2798064"/>
-            <a:ext cx="3200400" cy="201168"/>
-          </a:xfrm>
-          <a:prstGeom prst="rect">
-            <a:avLst/>
-          </a:prstGeom>
-          <a:noFill/>
-        </p:spPr>
-        <p:txBody>
-          <a:bodyPr wrap="square" lIns="0" rIns="0" tIns="0" bIns="0" anchor="t">
-            <a:spAutoFit/>
-          </a:bodyPr>
-          <a:lstStyle/>
-          <a:p>
-            <a:pPr algn="l"/>
-            <a:r>
-              <a:rPr sz="900" b="0">
-                <a:solidFill>
-                  <a:srgbClr val="64748B"/>
-                </a:solidFill>
-                <a:latin typeface="Segoe UI"/>
-              </a:rPr>
-              <a:t>All other services</a:t>
-            </a:r>
-          </a:p>
-        </p:txBody>
-      </p:sp>
-      <p:sp>
-        <p:nvSpPr>
-          <p:cNvPr id="25" name="TextBox 24"/>
-          <p:cNvSpPr txBox="1"/>
-          <p:nvPr/>
-        </p:nvSpPr>
-        <p:spPr>
-          <a:xfrm>
-            <a:off x="9875520" y="2798064"/>
-            <a:ext cx="1645920" cy="201168"/>
-          </a:xfrm>
-          <a:prstGeom prst="rect">
-            <a:avLst/>
-          </a:prstGeom>
-          <a:noFill/>
-        </p:spPr>
-        <p:txBody>
-          <a:bodyPr wrap="square" lIns="0" rIns="0" tIns="0" bIns="0" anchor="t">
-            <a:spAutoFit/>
-          </a:bodyPr>
-          <a:lstStyle/>
-          <a:p>
-            <a:pPr algn="r"/>
-            <a:r>
-              <a:rPr sz="900" b="0">
-                <a:solidFill>
-                  <a:srgbClr val="1E293B"/>
-                </a:solidFill>
-                <a:latin typeface="Segoe UI"/>
-              </a:rPr>
-              <a:t>$0.00</a:t>
-            </a:r>
-          </a:p>
-        </p:txBody>
-      </p:sp>
-      <p:cxnSp>
-        <p:nvCxnSpPr>
-          <p:cNvPr id="26" name="Connector 25"/>
-          <p:cNvCxnSpPr/>
-          <p:nvPr/>
-        </p:nvCxnSpPr>
-        <p:spPr>
-          <a:xfrm>
-            <a:off x="6446520" y="3063240"/>
-            <a:ext cx="5074920" cy="0"/>
-          </a:xfrm>
-          <a:prstGeom prst="line">
-            <a:avLst/>
-          </a:prstGeom>
-          <a:ln w="9525">
-            <a:solidFill>
-              <a:srgbClr val="E2E8F0"/>
-            </a:solidFill>
-          </a:ln>
-        </p:spPr>
-        <p:style>
-          <a:lnRef idx="2">
-            <a:schemeClr val="accent1"/>
-          </a:lnRef>
-          <a:fillRef idx="0">
-            <a:schemeClr val="accent1"/>
-          </a:fillRef>
-          <a:effectRef idx="1">
-            <a:schemeClr val="accent1"/>
-          </a:effectRef>
-          <a:fontRef idx="minor">
-            <a:schemeClr val="tx1"/>
-          </a:fontRef>
-        </p:style>
-      </p:cxnSp>
-      <p:sp>
-        <p:nvSpPr>
-          <p:cNvPr id="27" name="TextBox 26"/>
-          <p:cNvSpPr txBox="1"/>
-          <p:nvPr/>
-        </p:nvSpPr>
-        <p:spPr>
-          <a:xfrm>
-            <a:off x="6446520" y="3108960"/>
-            <a:ext cx="3200400" cy="274320"/>
-          </a:xfrm>
-          <a:prstGeom prst="rect">
-            <a:avLst/>
-          </a:prstGeom>
-          <a:noFill/>
-        </p:spPr>
-        <p:txBody>
-          <a:bodyPr wrap="square" lIns="0" rIns="0" tIns="0" bIns="0" anchor="t">
-            <a:spAutoFit/>
-          </a:bodyPr>
-          <a:lstStyle/>
-          <a:p>
-            <a:pPr algn="l"/>
-            <a:r>
-              <a:rPr sz="1100" b="1">
-                <a:solidFill>
-                  <a:srgbClr val="1E293B"/>
-                </a:solidFill>
-                <a:latin typeface="Segoe UI"/>
-              </a:rPr>
-              <a:t>TOTAL / user / month</a:t>
-            </a:r>
-          </a:p>
-        </p:txBody>
-      </p:sp>
-      <p:sp>
-        <p:nvSpPr>
-          <p:cNvPr id="28" name="TextBox 27"/>
-          <p:cNvSpPr txBox="1"/>
-          <p:nvPr/>
-        </p:nvSpPr>
-        <p:spPr>
-          <a:xfrm>
-            <a:off x="9875520" y="3108960"/>
-            <a:ext cx="1645920" cy="274320"/>
-          </a:xfrm>
-          <a:prstGeom prst="rect">
-            <a:avLst/>
-          </a:prstGeom>
-          <a:noFill/>
-        </p:spPr>
-        <p:txBody>
-          <a:bodyPr wrap="square" lIns="0" rIns="0" tIns="0" bIns="0" anchor="t">
-            <a:spAutoFit/>
-          </a:bodyPr>
-          <a:lstStyle/>
-          <a:p>
-            <a:pPr algn="r"/>
-            <a:r>
-              <a:rPr sz="1400" b="1">
-                <a:solidFill>
-                  <a:srgbClr val="16A34A"/>
-                </a:solidFill>
-                <a:latin typeface="Segoe UI"/>
-              </a:rPr>
-              <a:t>$0.13</a:t>
-            </a:r>
-          </a:p>
-        </p:txBody>
-      </p:sp>
-      <p:sp>
-        <p:nvSpPr>
-          <p:cNvPr id="29" name="TextBox 28"/>
-          <p:cNvSpPr txBox="1"/>
-          <p:nvPr/>
-        </p:nvSpPr>
-        <p:spPr>
-          <a:xfrm>
-            <a:off x="457200" y="3931920"/>
-            <a:ext cx="11247120" cy="365760"/>
-          </a:xfrm>
-          <a:prstGeom prst="rect">
-            <a:avLst/>
-          </a:prstGeom>
-          <a:noFill/>
-        </p:spPr>
-        <p:txBody>
-          <a:bodyPr wrap="square" lIns="0" rIns="0" tIns="0" bIns="0" anchor="t">
-            <a:spAutoFit/>
-          </a:bodyPr>
-          <a:lstStyle/>
-          <a:p>
-            <a:pPr algn="l"/>
-            <a:r>
-              <a:rPr sz="1300" b="1">
-                <a:solidFill>
-                  <a:srgbClr val="1E293B"/>
-                </a:solidFill>
-                <a:latin typeface="Segoe UI"/>
-              </a:rPr>
-              <a:t>What this means for Malaysia:</a:t>
-            </a:r>
-          </a:p>
-        </p:txBody>
-      </p:sp>
-      <p:sp>
-        <p:nvSpPr>
-          <p:cNvPr id="30" name="Rounded Rectangle 29"/>
+              <a:t>Backup: MOH Klinik Komuniti, NADI,
+Persatuan Diabetes Malaysia</a:t>
+            </a:r>
+          </a:p>
+        </p:txBody>
+      </p:sp>
+      <p:sp>
+        <p:nvSpPr>
+          <p:cNvPr id="21" name="Rounded Rectangle 20"/>
           <p:cNvSpPr/>
           <p:nvPr/>
         </p:nvSpPr>
         <p:spPr>
           <a:xfrm>
-            <a:off x="457200" y="4389120"/>
-            <a:ext cx="3703320" cy="2103120"/>
+            <a:off x="6217920" y="3840480"/>
+            <a:ext cx="5577840" cy="2468880"/>
           </a:xfrm>
           <a:prstGeom prst="roundRect">
             <a:avLst>
@@ -17455,14 +17148,329 @@
       </p:sp>
       <p:sp>
         <p:nvSpPr>
+          <p:cNvPr id="22" name="TextBox 21"/>
+          <p:cNvSpPr txBox="1"/>
+          <p:nvPr/>
+        </p:nvSpPr>
+        <p:spPr>
+          <a:xfrm>
+            <a:off x="6400800" y="3931920"/>
+            <a:ext cx="5212080" cy="274320"/>
+          </a:xfrm>
+          <a:prstGeom prst="rect">
+            <a:avLst/>
+          </a:prstGeom>
+          <a:noFill/>
+        </p:spPr>
+        <p:txBody>
+          <a:bodyPr wrap="square" lIns="0" rIns="0" tIns="0" bIns="0" anchor="t">
+            <a:spAutoFit/>
+          </a:bodyPr>
+          <a:lstStyle/>
+          <a:p>
+            <a:pPr algn="l"/>
+            <a:r>
+              <a:rPr sz="1200" b="1">
+                <a:solidFill>
+                  <a:srgbClr val="16A34A"/>
+                </a:solidFill>
+                <a:latin typeface="Segoe UI"/>
+              </a:rPr>
+              <a:t>💰  Cost per User / Month</a:t>
+            </a:r>
+          </a:p>
+        </p:txBody>
+      </p:sp>
+      <p:sp>
+        <p:nvSpPr>
+          <p:cNvPr id="23" name="TextBox 22"/>
+          <p:cNvSpPr txBox="1"/>
+          <p:nvPr/>
+        </p:nvSpPr>
+        <p:spPr>
+          <a:xfrm>
+            <a:off x="6400800" y="4297680"/>
+            <a:ext cx="3657600" cy="201168"/>
+          </a:xfrm>
+          <a:prstGeom prst="rect">
+            <a:avLst/>
+          </a:prstGeom>
+          <a:noFill/>
+        </p:spPr>
+        <p:txBody>
+          <a:bodyPr wrap="square" lIns="0" rIns="0" tIns="0" bIns="0" anchor="t">
+            <a:spAutoFit/>
+          </a:bodyPr>
+          <a:lstStyle/>
+          <a:p>
+            <a:pPr algn="l"/>
+            <a:r>
+              <a:rPr sz="1000" b="0">
+                <a:solidFill>
+                  <a:srgbClr val="64748B"/>
+                </a:solidFill>
+                <a:latin typeface="Segoe UI"/>
+              </a:rPr>
+              <a:t>Bedrock (200 chats)</a:t>
+            </a:r>
+          </a:p>
+        </p:txBody>
+      </p:sp>
+      <p:sp>
+        <p:nvSpPr>
+          <p:cNvPr id="24" name="TextBox 23"/>
+          <p:cNvSpPr txBox="1"/>
+          <p:nvPr/>
+        </p:nvSpPr>
+        <p:spPr>
+          <a:xfrm>
+            <a:off x="10058400" y="4297680"/>
+            <a:ext cx="1554480" cy="201168"/>
+          </a:xfrm>
+          <a:prstGeom prst="rect">
+            <a:avLst/>
+          </a:prstGeom>
+          <a:noFill/>
+        </p:spPr>
+        <p:txBody>
+          <a:bodyPr wrap="square" lIns="0" rIns="0" tIns="0" bIns="0" anchor="t">
+            <a:spAutoFit/>
+          </a:bodyPr>
+          <a:lstStyle/>
+          <a:p>
+            <a:pPr algn="r"/>
+            <a:r>
+              <a:rPr sz="1000" b="0">
+                <a:solidFill>
+                  <a:srgbClr val="1E293B"/>
+                </a:solidFill>
+                <a:latin typeface="Segoe UI"/>
+              </a:rPr>
+              <a:t>$0.10</a:t>
+            </a:r>
+          </a:p>
+        </p:txBody>
+      </p:sp>
+      <p:sp>
+        <p:nvSpPr>
+          <p:cNvPr id="25" name="TextBox 24"/>
+          <p:cNvSpPr txBox="1"/>
+          <p:nvPr/>
+        </p:nvSpPr>
+        <p:spPr>
+          <a:xfrm>
+            <a:off x="6400800" y="4526280"/>
+            <a:ext cx="3657600" cy="201168"/>
+          </a:xfrm>
+          <a:prstGeom prst="rect">
+            <a:avLst/>
+          </a:prstGeom>
+          <a:noFill/>
+        </p:spPr>
+        <p:txBody>
+          <a:bodyPr wrap="square" lIns="0" rIns="0" tIns="0" bIns="0" anchor="t">
+            <a:spAutoFit/>
+          </a:bodyPr>
+          <a:lstStyle/>
+          <a:p>
+            <a:pPr algn="l"/>
+            <a:r>
+              <a:rPr sz="1000" b="0">
+                <a:solidFill>
+                  <a:srgbClr val="64748B"/>
+                </a:solidFill>
+                <a:latin typeface="Segoe UI"/>
+              </a:rPr>
+              <a:t>Lambda + API Gateway</a:t>
+            </a:r>
+          </a:p>
+        </p:txBody>
+      </p:sp>
+      <p:sp>
+        <p:nvSpPr>
+          <p:cNvPr id="26" name="TextBox 25"/>
+          <p:cNvSpPr txBox="1"/>
+          <p:nvPr/>
+        </p:nvSpPr>
+        <p:spPr>
+          <a:xfrm>
+            <a:off x="10058400" y="4526280"/>
+            <a:ext cx="1554480" cy="201168"/>
+          </a:xfrm>
+          <a:prstGeom prst="rect">
+            <a:avLst/>
+          </a:prstGeom>
+          <a:noFill/>
+        </p:spPr>
+        <p:txBody>
+          <a:bodyPr wrap="square" lIns="0" rIns="0" tIns="0" bIns="0" anchor="t">
+            <a:spAutoFit/>
+          </a:bodyPr>
+          <a:lstStyle/>
+          <a:p>
+            <a:pPr algn="r"/>
+            <a:r>
+              <a:rPr sz="1000" b="0">
+                <a:solidFill>
+                  <a:srgbClr val="1E293B"/>
+                </a:solidFill>
+                <a:latin typeface="Segoe UI"/>
+              </a:rPr>
+              <a:t>Free tier</a:t>
+            </a:r>
+          </a:p>
+        </p:txBody>
+      </p:sp>
+      <p:sp>
+        <p:nvSpPr>
+          <p:cNvPr id="27" name="TextBox 26"/>
+          <p:cNvSpPr txBox="1"/>
+          <p:nvPr/>
+        </p:nvSpPr>
+        <p:spPr>
+          <a:xfrm>
+            <a:off x="6400800" y="4754880"/>
+            <a:ext cx="3657600" cy="201168"/>
+          </a:xfrm>
+          <a:prstGeom prst="rect">
+            <a:avLst/>
+          </a:prstGeom>
+          <a:noFill/>
+        </p:spPr>
+        <p:txBody>
+          <a:bodyPr wrap="square" lIns="0" rIns="0" tIns="0" bIns="0" anchor="t">
+            <a:spAutoFit/>
+          </a:bodyPr>
+          <a:lstStyle/>
+          <a:p>
+            <a:pPr algn="l"/>
+            <a:r>
+              <a:rPr sz="1000" b="0">
+                <a:solidFill>
+                  <a:srgbClr val="64748B"/>
+                </a:solidFill>
+                <a:latin typeface="Segoe UI"/>
+              </a:rPr>
+              <a:t>DynamoDB (3 tables)</a:t>
+            </a:r>
+          </a:p>
+        </p:txBody>
+      </p:sp>
+      <p:sp>
+        <p:nvSpPr>
+          <p:cNvPr id="28" name="TextBox 27"/>
+          <p:cNvSpPr txBox="1"/>
+          <p:nvPr/>
+        </p:nvSpPr>
+        <p:spPr>
+          <a:xfrm>
+            <a:off x="10058400" y="4754880"/>
+            <a:ext cx="1554480" cy="201168"/>
+          </a:xfrm>
+          <a:prstGeom prst="rect">
+            <a:avLst/>
+          </a:prstGeom>
+          <a:noFill/>
+        </p:spPr>
+        <p:txBody>
+          <a:bodyPr wrap="square" lIns="0" rIns="0" tIns="0" bIns="0" anchor="t">
+            <a:spAutoFit/>
+          </a:bodyPr>
+          <a:lstStyle/>
+          <a:p>
+            <a:pPr algn="r"/>
+            <a:r>
+              <a:rPr sz="1000" b="0">
+                <a:solidFill>
+                  <a:srgbClr val="1E293B"/>
+                </a:solidFill>
+                <a:latin typeface="Segoe UI"/>
+              </a:rPr>
+              <a:t>Free tier</a:t>
+            </a:r>
+          </a:p>
+        </p:txBody>
+      </p:sp>
+      <p:sp>
+        <p:nvSpPr>
+          <p:cNvPr id="29" name="TextBox 28"/>
+          <p:cNvSpPr txBox="1"/>
+          <p:nvPr/>
+        </p:nvSpPr>
+        <p:spPr>
+          <a:xfrm>
+            <a:off x="6400800" y="4983480"/>
+            <a:ext cx="3657600" cy="201168"/>
+          </a:xfrm>
+          <a:prstGeom prst="rect">
+            <a:avLst/>
+          </a:prstGeom>
+          <a:noFill/>
+        </p:spPr>
+        <p:txBody>
+          <a:bodyPr wrap="square" lIns="0" rIns="0" tIns="0" bIns="0" anchor="t">
+            <a:spAutoFit/>
+          </a:bodyPr>
+          <a:lstStyle/>
+          <a:p>
+            <a:pPr algn="l"/>
+            <a:r>
+              <a:rPr sz="1000" b="0">
+                <a:solidFill>
+                  <a:srgbClr val="64748B"/>
+                </a:solidFill>
+                <a:latin typeface="Segoe UI"/>
+              </a:rPr>
+              <a:t>SES + CloudFront + S3</a:t>
+            </a:r>
+          </a:p>
+        </p:txBody>
+      </p:sp>
+      <p:sp>
+        <p:nvSpPr>
+          <p:cNvPr id="30" name="TextBox 29"/>
+          <p:cNvSpPr txBox="1"/>
+          <p:nvPr/>
+        </p:nvSpPr>
+        <p:spPr>
+          <a:xfrm>
+            <a:off x="10058400" y="4983480"/>
+            <a:ext cx="1554480" cy="201168"/>
+          </a:xfrm>
+          <a:prstGeom prst="rect">
+            <a:avLst/>
+          </a:prstGeom>
+          <a:noFill/>
+        </p:spPr>
+        <p:txBody>
+          <a:bodyPr wrap="square" lIns="0" rIns="0" tIns="0" bIns="0" anchor="t">
+            <a:spAutoFit/>
+          </a:bodyPr>
+          <a:lstStyle/>
+          <a:p>
+            <a:pPr algn="r"/>
+            <a:r>
+              <a:rPr sz="1000" b="0">
+                <a:solidFill>
+                  <a:srgbClr val="1E293B"/>
+                </a:solidFill>
+                <a:latin typeface="Segoe UI"/>
+              </a:rPr>
+              <a:t>$0.03</a:t>
+            </a:r>
+          </a:p>
+        </p:txBody>
+      </p:sp>
+      <p:sp>
+        <p:nvSpPr>
           <p:cNvPr id="31" name="TextBox 30"/>
           <p:cNvSpPr txBox="1"/>
           <p:nvPr/>
         </p:nvSpPr>
         <p:spPr>
           <a:xfrm>
-            <a:off x="640080" y="4526280"/>
-            <a:ext cx="3291840" cy="274320"/>
+            <a:off x="6400800" y="5349240"/>
+            <a:ext cx="3657600" cy="274320"/>
           </a:xfrm>
           <a:prstGeom prst="rect">
             <a:avLst/>
@@ -17477,27 +17485,62 @@
           <a:p>
             <a:pPr algn="l"/>
             <a:r>
-              <a:rPr sz="1100" b="1">
+              <a:rPr sz="1200" b="1">
+                <a:solidFill>
+                  <a:srgbClr val="1E293B"/>
+                </a:solidFill>
+                <a:latin typeface="Segoe UI"/>
+              </a:rPr>
+              <a:t>TOTAL</a:t>
+            </a:r>
+          </a:p>
+        </p:txBody>
+      </p:sp>
+      <p:sp>
+        <p:nvSpPr>
+          <p:cNvPr id="32" name="TextBox 31"/>
+          <p:cNvSpPr txBox="1"/>
+          <p:nvPr/>
+        </p:nvSpPr>
+        <p:spPr>
+          <a:xfrm>
+            <a:off x="10058400" y="5349240"/>
+            <a:ext cx="1554480" cy="274320"/>
+          </a:xfrm>
+          <a:prstGeom prst="rect">
+            <a:avLst/>
+          </a:prstGeom>
+          <a:noFill/>
+        </p:spPr>
+        <p:txBody>
+          <a:bodyPr wrap="square" lIns="0" rIns="0" tIns="0" bIns="0" anchor="t">
+            <a:spAutoFit/>
+          </a:bodyPr>
+          <a:lstStyle/>
+          <a:p>
+            <a:pPr algn="r"/>
+            <a:r>
+              <a:rPr sz="1400" b="1">
                 <a:solidFill>
                   <a:srgbClr val="16A34A"/>
                 </a:solidFill>
                 <a:latin typeface="Segoe UI"/>
               </a:rPr>
-              <a:t>If deployed to 100K users</a:t>
-            </a:r>
-          </a:p>
-        </p:txBody>
-      </p:sp>
-      <p:sp>
-        <p:nvSpPr>
-          <p:cNvPr id="32" name="TextBox 31"/>
-          <p:cNvSpPr txBox="1"/>
-          <p:nvPr/>
-        </p:nvSpPr>
-        <p:spPr>
-          <a:xfrm>
-            <a:off x="640080" y="4846320"/>
-            <a:ext cx="3291840" cy="1371600"/>
+              <a:t>$0.13</a:t>
+            </a:r>
+          </a:p>
+        </p:txBody>
+      </p:sp>
+      <p:sp>
+        <p:nvSpPr>
+          <p:cNvPr id="33" name="TextBox 32"/>
+          <p:cNvSpPr txBox="1"/>
+          <p:nvPr/>
+        </p:nvSpPr>
+        <p:spPr>
+          <a:xfrm>
+            <a:off x="6400800" y="5669280"/>
+            <a:ext cx="5212080" cy="365760"/>
           </a:xfrm>
           <a:prstGeom prst="rect">
             <a:avLst/>
@@ -17512,99 +17555,49 @@
           <a:p>
             <a:pPr algn="l"/>
             <a:r>
-              <a:rPr sz="1000" b="0">
-                <a:solidFill>
-                  <a:srgbClr val="1E293B"/>
-                </a:solidFill>
-                <a:latin typeface="Segoe UI"/>
-              </a:rPr>
-              <a:t>• 50,000 fewer specialist visits/year
-• RM 240M saved (RM 2,400/patient)
-• 0.5% avg HbA1c reduction
-• 35% fewer complications (UKPDS)
-• 60% shorter wait times</a:t>
-            </a:r>
-          </a:p>
-        </p:txBody>
-      </p:sp>
-      <p:sp>
-        <p:nvSpPr>
-          <p:cNvPr id="33" name="Rounded Rectangle 32"/>
-          <p:cNvSpPr/>
-          <p:nvPr/>
-        </p:nvSpPr>
-        <p:spPr>
-          <a:xfrm>
-            <a:off x="4251960" y="4389120"/>
-            <a:ext cx="3703320" cy="2103120"/>
-          </a:xfrm>
-          <a:prstGeom prst="roundRect">
-            <a:avLst>
-              <a:gd name="adj" fmla="val 4000"/>
-            </a:avLst>
-          </a:prstGeom>
-          <a:solidFill>
-            <a:srgbClr val="F8FAFC"/>
-          </a:solidFill>
-          <a:ln w="9525">
-            <a:solidFill>
-              <a:srgbClr val="E2E8F0"/>
-            </a:solidFill>
-          </a:ln>
-        </p:spPr>
-        <p:style>
-          <a:lnRef idx="1">
-            <a:schemeClr val="accent1"/>
-          </a:lnRef>
-          <a:fillRef idx="3">
-            <a:schemeClr val="accent1"/>
-          </a:fillRef>
-          <a:effectRef idx="2">
-            <a:schemeClr val="accent1"/>
-          </a:effectRef>
-          <a:fontRef idx="minor">
-            <a:schemeClr val="lt1"/>
-          </a:fontRef>
-        </p:style>
-        <p:txBody>
-          <a:bodyPr rtlCol="0" anchor="ctr"/>
+              <a:rPr sz="900" b="0">
+                <a:solidFill>
+                  <a:srgbClr val="64748B"/>
+                </a:solidFill>
+                <a:latin typeface="Segoe UI"/>
+              </a:rPr>
+              <a:t>Less than half a ringgit per month.
+Sustainable without external funding.</a:t>
+            </a:r>
+          </a:p>
+        </p:txBody>
+      </p:sp>
+      <p:sp>
+        <p:nvSpPr>
+          <p:cNvPr id="34" name="TextBox 33"/>
+          <p:cNvSpPr txBox="1"/>
+          <p:nvPr/>
+        </p:nvSpPr>
+        <p:spPr>
+          <a:xfrm>
+            <a:off x="457200" y="6400800"/>
+            <a:ext cx="11247120" cy="274320"/>
+          </a:xfrm>
+          <a:prstGeom prst="rect">
+            <a:avLst/>
+          </a:prstGeom>
+          <a:noFill/>
+        </p:spPr>
+        <p:txBody>
+          <a:bodyPr wrap="square" lIns="0" rIns="0" tIns="0" bIns="0" anchor="t">
+            <a:spAutoFit/>
+          </a:bodyPr>
           <a:lstStyle/>
           <a:p>
             <a:pPr algn="ctr"/>
-          </a:p>
-        </p:txBody>
-      </p:sp>
-      <p:sp>
-        <p:nvSpPr>
-          <p:cNvPr id="34" name="TextBox 33"/>
-          <p:cNvSpPr txBox="1"/>
-          <p:nvPr/>
-        </p:nvSpPr>
-        <p:spPr>
-          <a:xfrm>
-            <a:off x="4434840" y="4526280"/>
-            <a:ext cx="3291840" cy="274320"/>
-          </a:xfrm>
-          <a:prstGeom prst="rect">
-            <a:avLst/>
-          </a:prstGeom>
-          <a:noFill/>
-        </p:spPr>
-        <p:txBody>
-          <a:bodyPr wrap="square" lIns="0" rIns="0" tIns="0" bIns="0" anchor="t">
-            <a:spAutoFit/>
-          </a:bodyPr>
-          <a:lstStyle/>
-          <a:p>
-            <a:pPr algn="l"/>
-            <a:r>
-              <a:rPr sz="1100" b="1">
-                <a:solidFill>
-                  <a:srgbClr val="D97706"/>
-                </a:solidFill>
-                <a:latin typeface="Segoe UI"/>
-              </a:rPr>
-              <a:t>What breaks at scale?</a:t>
+            <a:r>
+              <a:rPr sz="1000" b="1">
+                <a:solidFill>
+                  <a:srgbClr val="16A34A"/>
+                </a:solidFill>
+                <a:latin typeface="Segoe UI"/>
+              </a:rPr>
+              <a:t>At 100K users: 50K fewer specialist visits/year • RM 240M saved • 35% fewer complications</a:t>
             </a:r>
           </a:p>
         </p:txBody>
@@ -17612,167 +17605,6 @@
       <p:sp>
         <p:nvSpPr>
           <p:cNvPr id="35" name="TextBox 34"/>
-          <p:cNvSpPr txBox="1"/>
-          <p:nvPr/>
-        </p:nvSpPr>
-        <p:spPr>
-          <a:xfrm>
-            <a:off x="4434840" y="4846320"/>
-            <a:ext cx="3291840" cy="1371600"/>
-          </a:xfrm>
-          <a:prstGeom prst="rect">
-            <a:avLst/>
-          </a:prstGeom>
-          <a:noFill/>
-        </p:spPr>
-        <p:txBody>
-          <a:bodyPr wrap="square" lIns="0" rIns="0" tIns="0" bIns="0" anchor="t">
-            <a:spAutoFit/>
-          </a:bodyPr>
-          <a:lstStyle/>
-          <a:p>
-            <a:pPr algn="l"/>
-            <a:r>
-              <a:rPr sz="1000" b="0">
-                <a:solidFill>
-                  <a:srgbClr val="1E293B"/>
-                </a:solidFill>
-                <a:latin typeface="Segoe UI"/>
-              </a:rPr>
-              <a:t>• Bedrock rate limits → solved with
-  regional inference profiles
-• DynamoDB throughput → auto-scales
-• Cost at 100K = $13K/month
-  (vs $500K for 3 endocrinologists)</a:t>
-            </a:r>
-          </a:p>
-        </p:txBody>
-      </p:sp>
-      <p:sp>
-        <p:nvSpPr>
-          <p:cNvPr id="36" name="Rounded Rectangle 35"/>
-          <p:cNvSpPr/>
-          <p:nvPr/>
-        </p:nvSpPr>
-        <p:spPr>
-          <a:xfrm>
-            <a:off x="8046720" y="4389120"/>
-            <a:ext cx="3703320" cy="2103120"/>
-          </a:xfrm>
-          <a:prstGeom prst="roundRect">
-            <a:avLst>
-              <a:gd name="adj" fmla="val 4000"/>
-            </a:avLst>
-          </a:prstGeom>
-          <a:solidFill>
-            <a:srgbClr val="F8FAFC"/>
-          </a:solidFill>
-          <a:ln w="9525">
-            <a:solidFill>
-              <a:srgbClr val="E2E8F0"/>
-            </a:solidFill>
-          </a:ln>
-        </p:spPr>
-        <p:style>
-          <a:lnRef idx="1">
-            <a:schemeClr val="accent1"/>
-          </a:lnRef>
-          <a:fillRef idx="3">
-            <a:schemeClr val="accent1"/>
-          </a:fillRef>
-          <a:effectRef idx="2">
-            <a:schemeClr val="accent1"/>
-          </a:effectRef>
-          <a:fontRef idx="minor">
-            <a:schemeClr val="lt1"/>
-          </a:fontRef>
-        </p:style>
-        <p:txBody>
-          <a:bodyPr rtlCol="0" anchor="ctr"/>
-          <a:lstStyle/>
-          <a:p>
-            <a:pPr algn="ctr"/>
-          </a:p>
-        </p:txBody>
-      </p:sp>
-      <p:sp>
-        <p:nvSpPr>
-          <p:cNvPr id="37" name="TextBox 36"/>
-          <p:cNvSpPr txBox="1"/>
-          <p:nvPr/>
-        </p:nvSpPr>
-        <p:spPr>
-          <a:xfrm>
-            <a:off x="8229600" y="4526280"/>
-            <a:ext cx="3291840" cy="274320"/>
-          </a:xfrm>
-          <a:prstGeom prst="rect">
-            <a:avLst/>
-          </a:prstGeom>
-          <a:noFill/>
-        </p:spPr>
-        <p:txBody>
-          <a:bodyPr wrap="square" lIns="0" rIns="0" tIns="0" bIns="0" anchor="t">
-            <a:spAutoFit/>
-          </a:bodyPr>
-          <a:lstStyle/>
-          <a:p>
-            <a:pPr algn="l"/>
-            <a:r>
-              <a:rPr sz="1100" b="1">
-                <a:solidFill>
-                  <a:srgbClr val="D97706"/>
-                </a:solidFill>
-                <a:latin typeface="Segoe UI"/>
-              </a:rPr>
-              <a:t>Who gets left out?</a:t>
-            </a:r>
-          </a:p>
-        </p:txBody>
-      </p:sp>
-      <p:sp>
-        <p:nvSpPr>
-          <p:cNvPr id="38" name="TextBox 37"/>
-          <p:cNvSpPr txBox="1"/>
-          <p:nvPr/>
-        </p:nvSpPr>
-        <p:spPr>
-          <a:xfrm>
-            <a:off x="8229600" y="4846320"/>
-            <a:ext cx="3291840" cy="1371600"/>
-          </a:xfrm>
-          <a:prstGeom prst="rect">
-            <a:avLst/>
-          </a:prstGeom>
-          <a:noFill/>
-        </p:spPr>
-        <p:txBody>
-          <a:bodyPr wrap="square" lIns="0" rIns="0" tIns="0" bIns="0" anchor="t">
-            <a:spAutoFit/>
-          </a:bodyPr>
-          <a:lstStyle/>
-          <a:p>
-            <a:pPr algn="l"/>
-            <a:r>
-              <a:rPr sz="1000" b="0">
-                <a:solidFill>
-                  <a:srgbClr val="1E293B"/>
-                </a:solidFill>
-                <a:latin typeface="Segoe UI"/>
-              </a:rPr>
-              <a:t>• Elderly without smartphones →
-  Plan: USSD/SMS via SNS
-• Low literacy →
-  Plan: Voice input (Transcribe)
-• Rural connectivity →
-  Plan: Offline-first mobile app</a:t>
-            </a:r>
-          </a:p>
-        </p:txBody>
-      </p:sp>
-      <p:sp>
-        <p:nvSpPr>
-          <p:cNvPr id="39" name="TextBox 38"/>
           <p:cNvSpPr txBox="1"/>
           <p:nvPr/>
         </p:nvSpPr>

</xml_diff>